<commit_message>
Update timeline and title components for improved badge width estimation
</commit_message>
<xml_diff>
--- a/examples/demo_dark.pptx
+++ b/examples/demo_dark.pptx
@@ -4485,7 +4485,7 @@
         <p:spPr>
           <a:xfrm>
             <a:off x="685800" y="2011679"/>
-            <a:ext cx="9677095" cy="548640"/>
+            <a:ext cx="9503359" cy="548640"/>
           </a:xfrm>
           <a:prstGeom prst="rect">
             <a:avLst/>
@@ -4519,8 +4519,8 @@
         </p:nvSpPr>
         <p:spPr>
           <a:xfrm>
-            <a:off x="10545775" y="2125979"/>
-            <a:ext cx="1188720" cy="320040"/>
+            <a:off x="10372039" y="2125979"/>
+            <a:ext cx="1362456" cy="320040"/>
           </a:xfrm>
           <a:prstGeom prst="roundRect">
             <a:avLst>
@@ -4721,7 +4721,7 @@
         <p:spPr>
           <a:xfrm>
             <a:off x="685800" y="457200"/>
-            <a:ext cx="9677095" cy="548640"/>
+            <a:ext cx="8735263" cy="548640"/>
           </a:xfrm>
           <a:prstGeom prst="rect">
             <a:avLst/>
@@ -4755,8 +4755,8 @@
         </p:nvSpPr>
         <p:spPr>
           <a:xfrm>
-            <a:off x="10545775" y="571500"/>
-            <a:ext cx="1188720" cy="320040"/>
+            <a:off x="9603943" y="571500"/>
+            <a:ext cx="2130552" cy="320040"/>
           </a:xfrm>
           <a:prstGeom prst="roundRect">
             <a:avLst>
@@ -6421,7 +6421,7 @@
         <p:spPr>
           <a:xfrm>
             <a:off x="685800" y="457200"/>
-            <a:ext cx="9677095" cy="548640"/>
+            <a:ext cx="8927287" cy="548640"/>
           </a:xfrm>
           <a:prstGeom prst="rect">
             <a:avLst/>
@@ -6455,8 +6455,8 @@
         </p:nvSpPr>
         <p:spPr>
           <a:xfrm>
-            <a:off x="10545775" y="571500"/>
-            <a:ext cx="1188720" cy="320040"/>
+            <a:off x="9795967" y="571500"/>
+            <a:ext cx="1938528" cy="320040"/>
           </a:xfrm>
           <a:prstGeom prst="roundRect">
             <a:avLst>
@@ -6943,7 +6943,7 @@
             </a:avLst>
           </a:prstGeom>
           <a:solidFill>
-            <a:srgbClr val="334155"/>
+            <a:srgbClr val="94A3B8"/>
           </a:solidFill>
           <a:ln>
             <a:noFill/>
@@ -7058,7 +7058,7 @@
             </a:avLst>
           </a:prstGeom>
           <a:solidFill>
-            <a:srgbClr val="334155"/>
+            <a:srgbClr val="94A3B8"/>
           </a:solidFill>
           <a:ln>
             <a:noFill/>
@@ -15039,7 +15039,7 @@
         <p:spPr>
           <a:xfrm>
             <a:off x="685800" y="457200"/>
-            <a:ext cx="9677095" cy="548640"/>
+            <a:ext cx="9503359" cy="548640"/>
           </a:xfrm>
           <a:prstGeom prst="rect">
             <a:avLst/>
@@ -15073,8 +15073,8 @@
         </p:nvSpPr>
         <p:spPr>
           <a:xfrm>
-            <a:off x="10545775" y="571500"/>
-            <a:ext cx="1188720" cy="320040"/>
+            <a:off x="10372039" y="571500"/>
+            <a:ext cx="1362456" cy="320040"/>
           </a:xfrm>
           <a:prstGeom prst="roundRect">
             <a:avLst>

</xml_diff>

<commit_message>
Add scatter chart and animation components; update existing charts and layout
- Introduced ScatterChart and ScatterPlot components for XY scatter visualizations.
- Added animation effects: FadeInEffect, SlideInEffect, GrowEffect, and SequenceAnimation.
- Updated BarChart to deprecate the 'stacked' parameter in favor of 'mode'.
- Enhanced KPIGrid to use a cached grid representation for rendering.
- Improved GroupedTable for hierarchical data representation with group headers and footers.
- Refined layout calculations in Column and Grid components for consistent spacing.
- Added new utility functions for scatter chart data preparation.
- Updated theme management to ensure thread safety.
- Included new demo presentations for light and dark themes, and a scatter test presentation.
</commit_message>
<xml_diff>
--- a/examples/demo_dark.pptx
+++ b/examples/demo_dark.pptx
@@ -23,6 +23,11 @@
     <p:sldId id="271" r:id="rId22"/>
     <p:sldId id="272" r:id="rId23"/>
     <p:sldId id="273" r:id="rId24"/>
+    <p:sldId id="274" r:id="rId25"/>
+    <p:sldId id="275" r:id="rId26"/>
+    <p:sldId id="276" r:id="rId27"/>
+    <p:sldId id="277" r:id="rId28"/>
+    <p:sldId id="278" r:id="rId29"/>
   </p:sldIdLst>
   <p:sldSz cx="12191695" cy="6858000" type="screen4x3"/>
   <p:notesSz cx="6858000" cy="9144000"/>
@@ -22273,6 +22278,590 @@
 </p:sld>
 </file>
 
+<file path=ppt/slides/slide19.xml><?xml version="1.0" encoding="utf-8"?>
+<p:sld xmlns:a="http://schemas.openxmlformats.org/drawingml/2006/main" xmlns:p="http://schemas.openxmlformats.org/presentationml/2006/main" xmlns:r="http://schemas.openxmlformats.org/officeDocument/2006/relationships">
+  <p:cSld>
+    <p:bg>
+      <p:bgPr>
+        <a:solidFill>
+          <a:srgbClr val="0F172A"/>
+        </a:solidFill>
+        <a:effectLst/>
+      </p:bgPr>
+    </p:bg>
+    <p:spTree>
+      <p:nvGrpSpPr>
+        <p:cNvPr id="1" name=""/>
+        <p:cNvGrpSpPr/>
+        <p:nvPr/>
+      </p:nvGrpSpPr>
+      <p:grpSpPr/>
+      <p:sp>
+        <p:nvSpPr>
+          <p:cNvPr id="2" name="Rectangle 1"/>
+          <p:cNvSpPr/>
+          <p:nvPr/>
+        </p:nvSpPr>
+        <p:spPr>
+          <a:xfrm>
+            <a:off x="457200" y="457200"/>
+            <a:ext cx="45720" cy="548640"/>
+          </a:xfrm>
+          <a:prstGeom prst="rect">
+            <a:avLst/>
+          </a:prstGeom>
+          <a:solidFill>
+            <a:srgbClr val="3B82F6"/>
+          </a:solidFill>
+          <a:ln>
+            <a:noFill/>
+          </a:ln>
+        </p:spPr>
+        <p:style>
+          <a:lnRef idx="1">
+            <a:schemeClr val="accent1"/>
+          </a:lnRef>
+          <a:fillRef idx="3">
+            <a:schemeClr val="accent1"/>
+          </a:fillRef>
+          <a:effectRef idx="2">
+            <a:schemeClr val="accent1"/>
+          </a:effectRef>
+          <a:fontRef idx="minor">
+            <a:schemeClr val="lt1"/>
+          </a:fontRef>
+        </p:style>
+        <p:txBody>
+          <a:bodyPr rtlCol="0" anchor="ctr"/>
+          <a:lstStyle/>
+          <a:p>
+            <a:pPr algn="ctr"/>
+          </a:p>
+        </p:txBody>
+      </p:sp>
+      <p:sp>
+        <p:nvSpPr>
+          <p:cNvPr id="3" name="TextBox 2"/>
+          <p:cNvSpPr txBox="1"/>
+          <p:nvPr/>
+        </p:nvSpPr>
+        <p:spPr>
+          <a:xfrm>
+            <a:off x="685800" y="457200"/>
+            <a:ext cx="9677095" cy="548640"/>
+          </a:xfrm>
+          <a:prstGeom prst="rect">
+            <a:avLst/>
+          </a:prstGeom>
+          <a:noFill/>
+        </p:spPr>
+        <p:txBody>
+          <a:bodyPr wrap="square" lIns="0" tIns="0" rIns="0" bIns="0">
+            <a:spAutoFit/>
+          </a:bodyPr>
+          <a:lstStyle/>
+          <a:p>
+            <a:pPr algn="l"/>
+            <a:r>
+              <a:rPr sz="2800" b="1" i="0">
+                <a:solidFill>
+                  <a:srgbClr val="F8FAFC"/>
+                </a:solidFill>
+                <a:latin typeface="Calibri Light"/>
+              </a:rPr>
+              <a:t>Phase 5: Long-form Storytelling</a:t>
+            </a:r>
+          </a:p>
+        </p:txBody>
+      </p:sp>
+      <p:sp>
+        <p:nvSpPr>
+          <p:cNvPr id="4" name="Rounded Rectangle 3"/>
+          <p:cNvSpPr/>
+          <p:nvPr/>
+        </p:nvSpPr>
+        <p:spPr>
+          <a:xfrm>
+            <a:off x="10545775" y="571500"/>
+            <a:ext cx="1188720" cy="320040"/>
+          </a:xfrm>
+          <a:prstGeom prst="roundRect">
+            <a:avLst>
+              <a:gd name="adj" fmla="val 50000"/>
+            </a:avLst>
+          </a:prstGeom>
+          <a:solidFill>
+            <a:srgbClr val="3B82F6"/>
+          </a:solidFill>
+          <a:ln>
+            <a:noFill/>
+          </a:ln>
+        </p:spPr>
+        <p:style>
+          <a:lnRef idx="1">
+            <a:schemeClr val="accent1"/>
+          </a:lnRef>
+          <a:fillRef idx="3">
+            <a:schemeClr val="accent1"/>
+          </a:fillRef>
+          <a:effectRef idx="2">
+            <a:schemeClr val="accent1"/>
+          </a:effectRef>
+          <a:fontRef idx="minor">
+            <a:schemeClr val="lt1"/>
+          </a:fontRef>
+        </p:style>
+        <p:txBody>
+          <a:bodyPr rtlCol="0" anchor="ctr" wrap="none"/>
+          <a:lstStyle/>
+          <a:p>
+            <a:pPr algn="ctr"/>
+            <a:r>
+              <a:rPr sz="1100" b="1">
+                <a:solidFill>
+                  <a:srgbClr val="FFFFFF"/>
+                </a:solidFill>
+                <a:latin typeface="Calibri"/>
+              </a:rPr>
+              <a:t>Narrative</a:t>
+            </a:r>
+          </a:p>
+        </p:txBody>
+      </p:sp>
+      <p:sp>
+        <p:nvSpPr>
+          <p:cNvPr id="5" name="Rounded Rectangle 4"/>
+          <p:cNvSpPr/>
+          <p:nvPr/>
+        </p:nvSpPr>
+        <p:spPr>
+          <a:xfrm>
+            <a:off x="457200" y="1298448"/>
+            <a:ext cx="11277295" cy="4480560"/>
+          </a:xfrm>
+          <a:prstGeom prst="roundRect">
+            <a:avLst>
+              <a:gd name="adj" fmla="val 1020"/>
+            </a:avLst>
+          </a:prstGeom>
+          <a:solidFill>
+            <a:srgbClr val="1E293B"/>
+          </a:solidFill>
+          <a:ln>
+            <a:noFill/>
+          </a:ln>
+        </p:spPr>
+        <p:style>
+          <a:lnRef idx="1">
+            <a:schemeClr val="accent1"/>
+          </a:lnRef>
+          <a:fillRef idx="3">
+            <a:schemeClr val="accent1"/>
+          </a:fillRef>
+          <a:effectRef idx="2">
+            <a:schemeClr val="accent1"/>
+          </a:effectRef>
+          <a:fontRef idx="minor">
+            <a:schemeClr val="lt1"/>
+          </a:fontRef>
+        </p:style>
+        <p:txBody>
+          <a:bodyPr rtlCol="0" anchor="ctr"/>
+          <a:lstStyle/>
+          <a:p>
+            <a:pPr algn="ctr"/>
+          </a:p>
+        </p:txBody>
+      </p:sp>
+      <p:sp>
+        <p:nvSpPr>
+          <p:cNvPr id="6" name="Rectangle 5"/>
+          <p:cNvSpPr/>
+          <p:nvPr/>
+        </p:nvSpPr>
+        <p:spPr>
+          <a:xfrm>
+            <a:off x="457200" y="1298448"/>
+            <a:ext cx="11277295" cy="45720"/>
+          </a:xfrm>
+          <a:prstGeom prst="rect">
+            <a:avLst/>
+          </a:prstGeom>
+          <a:solidFill>
+            <a:srgbClr val="3B82F6"/>
+          </a:solidFill>
+          <a:ln>
+            <a:noFill/>
+          </a:ln>
+        </p:spPr>
+        <p:style>
+          <a:lnRef idx="1">
+            <a:schemeClr val="accent1"/>
+          </a:lnRef>
+          <a:fillRef idx="3">
+            <a:schemeClr val="accent1"/>
+          </a:fillRef>
+          <a:effectRef idx="2">
+            <a:schemeClr val="accent1"/>
+          </a:effectRef>
+          <a:fontRef idx="minor">
+            <a:schemeClr val="lt1"/>
+          </a:fontRef>
+        </p:style>
+        <p:txBody>
+          <a:bodyPr rtlCol="0" anchor="ctr"/>
+          <a:lstStyle/>
+          <a:p>
+            <a:pPr algn="ctr"/>
+          </a:p>
+        </p:txBody>
+      </p:sp>
+      <p:sp>
+        <p:nvSpPr>
+          <p:cNvPr id="7" name="TextBox 6"/>
+          <p:cNvSpPr txBox="1"/>
+          <p:nvPr/>
+        </p:nvSpPr>
+        <p:spPr>
+          <a:xfrm>
+            <a:off x="10637215" y="1481328"/>
+            <a:ext cx="914400" cy="228600"/>
+          </a:xfrm>
+          <a:prstGeom prst="rect">
+            <a:avLst/>
+          </a:prstGeom>
+          <a:noFill/>
+        </p:spPr>
+        <p:txBody>
+          <a:bodyPr wrap="square" lIns="0" tIns="0" rIns="0" bIns="0">
+            <a:spAutoFit/>
+          </a:bodyPr>
+          <a:lstStyle/>
+          <a:p>
+            <a:pPr algn="r"/>
+            <a:r>
+              <a:rPr sz="1100" b="1" i="0">
+                <a:solidFill>
+                  <a:srgbClr val="94A3B8"/>
+                </a:solidFill>
+                <a:latin typeface="Calibri"/>
+              </a:rPr>
+              <a:t>Page 1/1</a:t>
+            </a:r>
+          </a:p>
+        </p:txBody>
+      </p:sp>
+      <p:sp>
+        <p:nvSpPr>
+          <p:cNvPr id="8" name="TextBox 7"/>
+          <p:cNvSpPr txBox="1"/>
+          <p:nvPr/>
+        </p:nvSpPr>
+        <p:spPr>
+          <a:xfrm>
+            <a:off x="640080" y="1481328"/>
+            <a:ext cx="9997135" cy="320040"/>
+          </a:xfrm>
+          <a:prstGeom prst="rect">
+            <a:avLst/>
+          </a:prstGeom>
+          <a:noFill/>
+        </p:spPr>
+        <p:txBody>
+          <a:bodyPr wrap="square" lIns="0" tIns="0" rIns="0" bIns="0">
+            <a:spAutoFit/>
+          </a:bodyPr>
+          <a:lstStyle/>
+          <a:p>
+            <a:pPr algn="l"/>
+            <a:r>
+              <a:rPr sz="2000" b="1" i="0">
+                <a:solidFill>
+                  <a:srgbClr val="F8FAFC"/>
+                </a:solidFill>
+                <a:latin typeface="Calibri Light"/>
+              </a:rPr>
+              <a:t>Executive Narrative - Structured View</a:t>
+            </a:r>
+          </a:p>
+        </p:txBody>
+      </p:sp>
+      <p:sp>
+        <p:nvSpPr>
+          <p:cNvPr id="9" name="TextBox 8"/>
+          <p:cNvSpPr txBox="1"/>
+          <p:nvPr/>
+        </p:nvSpPr>
+        <p:spPr>
+          <a:xfrm>
+            <a:off x="640080" y="1801367"/>
+            <a:ext cx="10911535" cy="256032"/>
+          </a:xfrm>
+          <a:prstGeom prst="rect">
+            <a:avLst/>
+          </a:prstGeom>
+          <a:noFill/>
+        </p:spPr>
+        <p:txBody>
+          <a:bodyPr wrap="square" lIns="0" tIns="0" rIns="0" bIns="0">
+            <a:spAutoFit/>
+          </a:bodyPr>
+          <a:lstStyle/>
+          <a:p>
+            <a:pPr algn="l"/>
+            <a:r>
+              <a:rPr sz="1100" b="0" i="0">
+                <a:solidFill>
+                  <a:srgbClr val="94A3B8"/>
+                </a:solidFill>
+                <a:latin typeface="Calibri"/>
+              </a:rPr>
+              <a:t>Narrative in one slide with decision support rail.</a:t>
+            </a:r>
+          </a:p>
+        </p:txBody>
+      </p:sp>
+      <p:sp>
+        <p:nvSpPr>
+          <p:cNvPr id="10" name="Rounded Rectangle 9"/>
+          <p:cNvSpPr/>
+          <p:nvPr/>
+        </p:nvSpPr>
+        <p:spPr>
+          <a:xfrm>
+            <a:off x="640080" y="2093975"/>
+            <a:ext cx="7485680" cy="3502152"/>
+          </a:xfrm>
+          <a:prstGeom prst="roundRect">
+            <a:avLst>
+              <a:gd name="adj" fmla="val 783"/>
+            </a:avLst>
+          </a:prstGeom>
+          <a:solidFill>
+            <a:srgbClr val="0F172A"/>
+          </a:solidFill>
+          <a:ln>
+            <a:noFill/>
+          </a:ln>
+        </p:spPr>
+        <p:style>
+          <a:lnRef idx="1">
+            <a:schemeClr val="accent1"/>
+          </a:lnRef>
+          <a:fillRef idx="3">
+            <a:schemeClr val="accent1"/>
+          </a:fillRef>
+          <a:effectRef idx="2">
+            <a:schemeClr val="accent1"/>
+          </a:effectRef>
+          <a:fontRef idx="minor">
+            <a:schemeClr val="lt1"/>
+          </a:fontRef>
+        </p:style>
+        <p:txBody>
+          <a:bodyPr rtlCol="0" anchor="ctr"/>
+          <a:lstStyle/>
+          <a:p>
+            <a:pPr algn="ctr"/>
+          </a:p>
+        </p:txBody>
+      </p:sp>
+      <p:sp>
+        <p:nvSpPr>
+          <p:cNvPr id="11" name="TextBox 10"/>
+          <p:cNvSpPr txBox="1"/>
+          <p:nvPr/>
+        </p:nvSpPr>
+        <p:spPr>
+          <a:xfrm>
+            <a:off x="768096" y="2203703"/>
+            <a:ext cx="7229648" cy="3282696"/>
+          </a:xfrm>
+          <a:prstGeom prst="rect">
+            <a:avLst/>
+          </a:prstGeom>
+          <a:noFill/>
+        </p:spPr>
+        <p:txBody>
+          <a:bodyPr wrap="square" lIns="0" tIns="0" rIns="0" bIns="0">
+            <a:spAutoFit/>
+          </a:bodyPr>
+          <a:lstStyle/>
+          <a:p>
+            <a:pPr algn="l"/>
+            <a:r>
+              <a:rPr sz="1400" b="0" i="0">
+                <a:solidFill>
+                  <a:srgbClr val="CBD5E1"/>
+                </a:solidFill>
+                <a:latin typeface="Calibri"/>
+              </a:rPr>
+              <a:t>Q2 performance stabilized after concentration risk mitigation and onboarding process redesign. Margin expansion creates room for selective reinvestment, but service quality and migration complexity still require focused execution through Q3.</a:t>
+            </a:r>
+          </a:p>
+        </p:txBody>
+      </p:sp>
+      <p:sp>
+        <p:nvSpPr>
+          <p:cNvPr id="12" name="Rounded Rectangle 11"/>
+          <p:cNvSpPr/>
+          <p:nvPr/>
+        </p:nvSpPr>
+        <p:spPr>
+          <a:xfrm>
+            <a:off x="8144048" y="2093975"/>
+            <a:ext cx="3242974" cy="3502152"/>
+          </a:xfrm>
+          <a:prstGeom prst="roundRect">
+            <a:avLst>
+              <a:gd name="adj" fmla="val 844"/>
+            </a:avLst>
+          </a:prstGeom>
+          <a:solidFill>
+            <a:srgbClr val="334155"/>
+          </a:solidFill>
+          <a:ln>
+            <a:noFill/>
+          </a:ln>
+        </p:spPr>
+        <p:style>
+          <a:lnRef idx="1">
+            <a:schemeClr val="accent1"/>
+          </a:lnRef>
+          <a:fillRef idx="3">
+            <a:schemeClr val="accent1"/>
+          </a:fillRef>
+          <a:effectRef idx="2">
+            <a:schemeClr val="accent1"/>
+          </a:effectRef>
+          <a:fontRef idx="minor">
+            <a:schemeClr val="lt1"/>
+          </a:fontRef>
+        </p:style>
+        <p:txBody>
+          <a:bodyPr rtlCol="0" anchor="ctr"/>
+          <a:lstStyle/>
+          <a:p>
+            <a:pPr algn="ctr"/>
+          </a:p>
+        </p:txBody>
+      </p:sp>
+      <p:sp>
+        <p:nvSpPr>
+          <p:cNvPr id="13" name="TextBox 12"/>
+          <p:cNvSpPr txBox="1"/>
+          <p:nvPr/>
+        </p:nvSpPr>
+        <p:spPr>
+          <a:xfrm>
+            <a:off x="8253776" y="2185415"/>
+            <a:ext cx="3023518" cy="228600"/>
+          </a:xfrm>
+          <a:prstGeom prst="rect">
+            <a:avLst/>
+          </a:prstGeom>
+          <a:noFill/>
+        </p:spPr>
+        <p:txBody>
+          <a:bodyPr wrap="square" lIns="0" tIns="0" rIns="0" bIns="0">
+            <a:spAutoFit/>
+          </a:bodyPr>
+          <a:lstStyle/>
+          <a:p>
+            <a:pPr algn="l"/>
+            <a:r>
+              <a:rPr sz="1100" b="1" i="0">
+                <a:solidFill>
+                  <a:srgbClr val="F8FAFC"/>
+                </a:solidFill>
+                <a:latin typeface="Calibri"/>
+              </a:rPr>
+              <a:t>Decision Lens</a:t>
+            </a:r>
+          </a:p>
+        </p:txBody>
+      </p:sp>
+      <p:sp>
+        <p:nvSpPr>
+          <p:cNvPr id="14" name="TextBox 13"/>
+          <p:cNvSpPr txBox="1"/>
+          <p:nvPr/>
+        </p:nvSpPr>
+        <p:spPr>
+          <a:xfrm>
+            <a:off x="8253776" y="2404871"/>
+            <a:ext cx="3023518" cy="2311420"/>
+          </a:xfrm>
+          <a:prstGeom prst="rect">
+            <a:avLst/>
+          </a:prstGeom>
+          <a:noFill/>
+        </p:spPr>
+        <p:txBody>
+          <a:bodyPr wrap="square" lIns="0" tIns="0" rIns="0" bIns="0">
+            <a:spAutoFit/>
+          </a:bodyPr>
+          <a:lstStyle/>
+          <a:p>
+            <a:pPr algn="l"/>
+            <a:r>
+              <a:rPr sz="1100" b="0" i="0">
+                <a:solidFill>
+                  <a:srgbClr val="CBD5E1"/>
+                </a:solidFill>
+                <a:latin typeface="Calibri"/>
+              </a:rPr>
+              <a:t>- Protect margin gains
+- Reduce support load
+- Prioritize retention levers
+- Tighten ownership by workflow</a:t>
+            </a:r>
+          </a:p>
+        </p:txBody>
+      </p:sp>
+      <p:sp>
+        <p:nvSpPr>
+          <p:cNvPr id="15" name="TextBox 14"/>
+          <p:cNvSpPr txBox="1"/>
+          <p:nvPr/>
+        </p:nvSpPr>
+        <p:spPr>
+          <a:xfrm>
+            <a:off x="8253776" y="4956048"/>
+            <a:ext cx="3023518" cy="530352"/>
+          </a:xfrm>
+          <a:prstGeom prst="rect">
+            <a:avLst/>
+          </a:prstGeom>
+          <a:noFill/>
+        </p:spPr>
+        <p:txBody>
+          <a:bodyPr wrap="square" lIns="0" tIns="0" rIns="0" bIns="0">
+            <a:spAutoFit/>
+          </a:bodyPr>
+          <a:lstStyle/>
+          <a:p>
+            <a:pPr algn="l"/>
+            <a:r>
+              <a:rPr sz="1100" b="1" i="0">
+                <a:solidFill>
+                  <a:srgbClr val="3B82F6"/>
+                </a:solidFill>
+                <a:latin typeface="Calibri"/>
+              </a:rPr>
+              <a:t>Next review: validate churn trend by segment.</a:t>
+            </a:r>
+          </a:p>
+        </p:txBody>
+      </p:sp>
+    </p:spTree>
+  </p:cSld>
+  <p:clrMapOvr>
+    <a:masterClrMapping/>
+  </p:clrMapOvr>
+</p:sld>
+</file>
+
 <file path=ppt/slides/slide2.xml><?xml version="1.0" encoding="utf-8"?>
 <p:sld xmlns:a="http://schemas.openxmlformats.org/drawingml/2006/main" xmlns:p="http://schemas.openxmlformats.org/presentationml/2006/main" xmlns:r="http://schemas.openxmlformats.org/officeDocument/2006/relationships">
   <p:cSld>
@@ -23313,6 +23902,2442 @@
                 <a:latin typeface="Calibri"/>
               </a:rPr>
               <a:t>Customer acquisition cost</a:t>
+            </a:r>
+          </a:p>
+        </p:txBody>
+      </p:sp>
+    </p:spTree>
+  </p:cSld>
+  <p:clrMapOvr>
+    <a:masterClrMapping/>
+  </p:clrMapOvr>
+</p:sld>
+</file>
+
+<file path=ppt/slides/slide20.xml><?xml version="1.0" encoding="utf-8"?>
+<p:sld xmlns:a="http://schemas.openxmlformats.org/drawingml/2006/main" xmlns:p="http://schemas.openxmlformats.org/presentationml/2006/main" xmlns:r="http://schemas.openxmlformats.org/officeDocument/2006/relationships">
+  <p:cSld>
+    <p:bg>
+      <p:bgPr>
+        <a:solidFill>
+          <a:srgbClr val="0F172A"/>
+        </a:solidFill>
+        <a:effectLst/>
+      </p:bgPr>
+    </p:bg>
+    <p:spTree>
+      <p:nvGrpSpPr>
+        <p:cNvPr id="1" name=""/>
+        <p:cNvGrpSpPr/>
+        <p:nvPr/>
+      </p:nvGrpSpPr>
+      <p:grpSpPr/>
+      <p:sp>
+        <p:nvSpPr>
+          <p:cNvPr id="2" name="Rounded Rectangle 1"/>
+          <p:cNvSpPr/>
+          <p:nvPr/>
+        </p:nvSpPr>
+        <p:spPr>
+          <a:xfrm>
+            <a:off x="457200" y="457200"/>
+            <a:ext cx="11277295" cy="5943600"/>
+          </a:xfrm>
+          <a:prstGeom prst="roundRect">
+            <a:avLst>
+              <a:gd name="adj" fmla="val 769"/>
+            </a:avLst>
+          </a:prstGeom>
+          <a:solidFill>
+            <a:srgbClr val="1E293B"/>
+          </a:solidFill>
+          <a:ln>
+            <a:noFill/>
+          </a:ln>
+        </p:spPr>
+        <p:style>
+          <a:lnRef idx="1">
+            <a:schemeClr val="accent1"/>
+          </a:lnRef>
+          <a:fillRef idx="3">
+            <a:schemeClr val="accent1"/>
+          </a:fillRef>
+          <a:effectRef idx="2">
+            <a:schemeClr val="accent1"/>
+          </a:effectRef>
+          <a:fontRef idx="minor">
+            <a:schemeClr val="lt1"/>
+          </a:fontRef>
+        </p:style>
+        <p:txBody>
+          <a:bodyPr rtlCol="0" anchor="ctr"/>
+          <a:lstStyle/>
+          <a:p>
+            <a:pPr algn="ctr"/>
+          </a:p>
+        </p:txBody>
+      </p:sp>
+      <p:sp>
+        <p:nvSpPr>
+          <p:cNvPr id="3" name="Rectangle 2"/>
+          <p:cNvSpPr/>
+          <p:nvPr/>
+        </p:nvSpPr>
+        <p:spPr>
+          <a:xfrm>
+            <a:off x="457200" y="457200"/>
+            <a:ext cx="11277295" cy="45720"/>
+          </a:xfrm>
+          <a:prstGeom prst="rect">
+            <a:avLst/>
+          </a:prstGeom>
+          <a:solidFill>
+            <a:srgbClr val="3B82F6"/>
+          </a:solidFill>
+          <a:ln>
+            <a:noFill/>
+          </a:ln>
+        </p:spPr>
+        <p:style>
+          <a:lnRef idx="1">
+            <a:schemeClr val="accent1"/>
+          </a:lnRef>
+          <a:fillRef idx="3">
+            <a:schemeClr val="accent1"/>
+          </a:fillRef>
+          <a:effectRef idx="2">
+            <a:schemeClr val="accent1"/>
+          </a:effectRef>
+          <a:fontRef idx="minor">
+            <a:schemeClr val="lt1"/>
+          </a:fontRef>
+        </p:style>
+        <p:txBody>
+          <a:bodyPr rtlCol="0" anchor="ctr"/>
+          <a:lstStyle/>
+          <a:p>
+            <a:pPr algn="ctr"/>
+          </a:p>
+        </p:txBody>
+      </p:sp>
+      <p:sp>
+        <p:nvSpPr>
+          <p:cNvPr id="4" name="TextBox 3"/>
+          <p:cNvSpPr txBox="1"/>
+          <p:nvPr/>
+        </p:nvSpPr>
+        <p:spPr>
+          <a:xfrm>
+            <a:off x="10637215" y="640080"/>
+            <a:ext cx="914400" cy="228600"/>
+          </a:xfrm>
+          <a:prstGeom prst="rect">
+            <a:avLst/>
+          </a:prstGeom>
+          <a:noFill/>
+        </p:spPr>
+        <p:txBody>
+          <a:bodyPr wrap="square" lIns="0" tIns="0" rIns="0" bIns="0">
+            <a:spAutoFit/>
+          </a:bodyPr>
+          <a:lstStyle/>
+          <a:p>
+            <a:pPr algn="r"/>
+            <a:r>
+              <a:rPr sz="1100" b="1" i="0">
+                <a:solidFill>
+                  <a:srgbClr val="94A3B8"/>
+                </a:solidFill>
+                <a:latin typeface="Calibri"/>
+              </a:rPr>
+              <a:t>Page 1/3</a:t>
+            </a:r>
+          </a:p>
+        </p:txBody>
+      </p:sp>
+      <p:sp>
+        <p:nvSpPr>
+          <p:cNvPr id="5" name="TextBox 4"/>
+          <p:cNvSpPr txBox="1"/>
+          <p:nvPr/>
+        </p:nvSpPr>
+        <p:spPr>
+          <a:xfrm>
+            <a:off x="640080" y="640080"/>
+            <a:ext cx="9997135" cy="320040"/>
+          </a:xfrm>
+          <a:prstGeom prst="rect">
+            <a:avLst/>
+          </a:prstGeom>
+          <a:noFill/>
+        </p:spPr>
+        <p:txBody>
+          <a:bodyPr wrap="square" lIns="0" tIns="0" rIns="0" bIns="0">
+            <a:spAutoFit/>
+          </a:bodyPr>
+          <a:lstStyle/>
+          <a:p>
+            <a:pPr algn="l"/>
+            <a:r>
+              <a:rPr sz="2000" b="1" i="0">
+                <a:solidFill>
+                  <a:srgbClr val="F8FAFC"/>
+                </a:solidFill>
+                <a:latin typeface="Calibri Light"/>
+              </a:rPr>
+              <a:t>Executive Narrative - Auto Paginated</a:t>
+            </a:r>
+          </a:p>
+        </p:txBody>
+      </p:sp>
+      <p:sp>
+        <p:nvSpPr>
+          <p:cNvPr id="6" name="TextBox 5"/>
+          <p:cNvSpPr txBox="1"/>
+          <p:nvPr/>
+        </p:nvSpPr>
+        <p:spPr>
+          <a:xfrm>
+            <a:off x="640080" y="960119"/>
+            <a:ext cx="10911535" cy="256032"/>
+          </a:xfrm>
+          <a:prstGeom prst="rect">
+            <a:avLst/>
+          </a:prstGeom>
+          <a:noFill/>
+        </p:spPr>
+        <p:txBody>
+          <a:bodyPr wrap="square" lIns="0" tIns="0" rIns="0" bIns="0">
+            <a:spAutoFit/>
+          </a:bodyPr>
+          <a:lstStyle/>
+          <a:p>
+            <a:pPr algn="l"/>
+            <a:r>
+              <a:rPr sz="1100" b="0" i="0">
+                <a:solidFill>
+                  <a:srgbClr val="94A3B8"/>
+                </a:solidFill>
+                <a:latin typeface="Calibri"/>
+              </a:rPr>
+              <a:t>Long text automatically split into multiple slides.</a:t>
+            </a:r>
+          </a:p>
+        </p:txBody>
+      </p:sp>
+      <p:sp>
+        <p:nvSpPr>
+          <p:cNvPr id="7" name="Rounded Rectangle 6"/>
+          <p:cNvSpPr/>
+          <p:nvPr/>
+        </p:nvSpPr>
+        <p:spPr>
+          <a:xfrm>
+            <a:off x="640080" y="1252728"/>
+            <a:ext cx="7485680" cy="4965192"/>
+          </a:xfrm>
+          <a:prstGeom prst="roundRect">
+            <a:avLst>
+              <a:gd name="adj" fmla="val 552"/>
+            </a:avLst>
+          </a:prstGeom>
+          <a:solidFill>
+            <a:srgbClr val="0F172A"/>
+          </a:solidFill>
+          <a:ln>
+            <a:noFill/>
+          </a:ln>
+        </p:spPr>
+        <p:style>
+          <a:lnRef idx="1">
+            <a:schemeClr val="accent1"/>
+          </a:lnRef>
+          <a:fillRef idx="3">
+            <a:schemeClr val="accent1"/>
+          </a:fillRef>
+          <a:effectRef idx="2">
+            <a:schemeClr val="accent1"/>
+          </a:effectRef>
+          <a:fontRef idx="minor">
+            <a:schemeClr val="lt1"/>
+          </a:fontRef>
+        </p:style>
+        <p:txBody>
+          <a:bodyPr rtlCol="0" anchor="ctr"/>
+          <a:lstStyle/>
+          <a:p>
+            <a:pPr algn="ctr"/>
+          </a:p>
+        </p:txBody>
+      </p:sp>
+      <p:sp>
+        <p:nvSpPr>
+          <p:cNvPr id="8" name="TextBox 7"/>
+          <p:cNvSpPr txBox="1"/>
+          <p:nvPr/>
+        </p:nvSpPr>
+        <p:spPr>
+          <a:xfrm>
+            <a:off x="768096" y="1362455"/>
+            <a:ext cx="7229648" cy="4745736"/>
+          </a:xfrm>
+          <a:prstGeom prst="rect">
+            <a:avLst/>
+          </a:prstGeom>
+          <a:noFill/>
+        </p:spPr>
+        <p:txBody>
+          <a:bodyPr wrap="square" lIns="0" tIns="0" rIns="0" bIns="0">
+            <a:spAutoFit/>
+          </a:bodyPr>
+          <a:lstStyle/>
+          <a:p>
+            <a:pPr algn="l"/>
+            <a:r>
+              <a:rPr sz="1400" b="0" i="0">
+                <a:solidFill>
+                  <a:srgbClr val="CBD5E1"/>
+                </a:solidFill>
+                <a:latin typeface="Calibri"/>
+              </a:rPr>
+              <a:t>Q2 opened with concentrated enterprise exposure: two strategic accounts represented 28% of net new ARR and introduced procurement timing risk. The commercial team reduced dependency by improving mid-market coverage, tightening qualification standards, and rebalancing outbound sequences toward faster-velocity segments.
+(continued on next slide)</a:t>
+            </a:r>
+          </a:p>
+        </p:txBody>
+      </p:sp>
+      <p:sp>
+        <p:nvSpPr>
+          <p:cNvPr id="9" name="Rounded Rectangle 8"/>
+          <p:cNvSpPr/>
+          <p:nvPr/>
+        </p:nvSpPr>
+        <p:spPr>
+          <a:xfrm>
+            <a:off x="8144048" y="1252728"/>
+            <a:ext cx="3242974" cy="4965192"/>
+          </a:xfrm>
+          <a:prstGeom prst="roundRect">
+            <a:avLst>
+              <a:gd name="adj" fmla="val 844"/>
+            </a:avLst>
+          </a:prstGeom>
+          <a:solidFill>
+            <a:srgbClr val="334155"/>
+          </a:solidFill>
+          <a:ln>
+            <a:noFill/>
+          </a:ln>
+        </p:spPr>
+        <p:style>
+          <a:lnRef idx="1">
+            <a:schemeClr val="accent1"/>
+          </a:lnRef>
+          <a:fillRef idx="3">
+            <a:schemeClr val="accent1"/>
+          </a:fillRef>
+          <a:effectRef idx="2">
+            <a:schemeClr val="accent1"/>
+          </a:effectRef>
+          <a:fontRef idx="minor">
+            <a:schemeClr val="lt1"/>
+          </a:fontRef>
+        </p:style>
+        <p:txBody>
+          <a:bodyPr rtlCol="0" anchor="ctr"/>
+          <a:lstStyle/>
+          <a:p>
+            <a:pPr algn="ctr"/>
+          </a:p>
+        </p:txBody>
+      </p:sp>
+      <p:sp>
+        <p:nvSpPr>
+          <p:cNvPr id="10" name="TextBox 9"/>
+          <p:cNvSpPr txBox="1"/>
+          <p:nvPr/>
+        </p:nvSpPr>
+        <p:spPr>
+          <a:xfrm>
+            <a:off x="8253776" y="1344168"/>
+            <a:ext cx="3023518" cy="228600"/>
+          </a:xfrm>
+          <a:prstGeom prst="rect">
+            <a:avLst/>
+          </a:prstGeom>
+          <a:noFill/>
+        </p:spPr>
+        <p:txBody>
+          <a:bodyPr wrap="square" lIns="0" tIns="0" rIns="0" bIns="0">
+            <a:spAutoFit/>
+          </a:bodyPr>
+          <a:lstStyle/>
+          <a:p>
+            <a:pPr algn="l"/>
+            <a:r>
+              <a:rPr sz="1100" b="1" i="0">
+                <a:solidFill>
+                  <a:srgbClr val="F8FAFC"/>
+                </a:solidFill>
+                <a:latin typeface="Calibri"/>
+              </a:rPr>
+              <a:t>Steering Notes</a:t>
+            </a:r>
+          </a:p>
+        </p:txBody>
+      </p:sp>
+      <p:sp>
+        <p:nvSpPr>
+          <p:cNvPr id="11" name="TextBox 10"/>
+          <p:cNvSpPr txBox="1"/>
+          <p:nvPr/>
+        </p:nvSpPr>
+        <p:spPr>
+          <a:xfrm>
+            <a:off x="8253776" y="1563624"/>
+            <a:ext cx="3023518" cy="3277026"/>
+          </a:xfrm>
+          <a:prstGeom prst="rect">
+            <a:avLst/>
+          </a:prstGeom>
+          <a:noFill/>
+        </p:spPr>
+        <p:txBody>
+          <a:bodyPr wrap="square" lIns="0" tIns="0" rIns="0" bIns="0">
+            <a:spAutoFit/>
+          </a:bodyPr>
+          <a:lstStyle/>
+          <a:p>
+            <a:pPr algn="l"/>
+            <a:r>
+              <a:rPr sz="1100" b="0" i="0">
+                <a:solidFill>
+                  <a:srgbClr val="CBD5E1"/>
+                </a:solidFill>
+                <a:latin typeface="Calibri"/>
+              </a:rPr>
+              <a:t>- Watch enterprise concentration
+- Keep onboarding gains sticky
+- Fund observability upgrades
+- Track p95 latency weekly</a:t>
+            </a:r>
+          </a:p>
+        </p:txBody>
+      </p:sp>
+      <p:sp>
+        <p:nvSpPr>
+          <p:cNvPr id="12" name="TextBox 11"/>
+          <p:cNvSpPr txBox="1"/>
+          <p:nvPr/>
+        </p:nvSpPr>
+        <p:spPr>
+          <a:xfrm>
+            <a:off x="8253776" y="5577840"/>
+            <a:ext cx="3023518" cy="530352"/>
+          </a:xfrm>
+          <a:prstGeom prst="rect">
+            <a:avLst/>
+          </a:prstGeom>
+          <a:noFill/>
+        </p:spPr>
+        <p:txBody>
+          <a:bodyPr wrap="square" lIns="0" tIns="0" rIns="0" bIns="0">
+            <a:spAutoFit/>
+          </a:bodyPr>
+          <a:lstStyle/>
+          <a:p>
+            <a:pPr algn="l"/>
+            <a:r>
+              <a:rPr sz="1100" b="1" i="0">
+                <a:solidFill>
+                  <a:srgbClr val="3B82F6"/>
+                </a:solidFill>
+                <a:latin typeface="Calibri"/>
+              </a:rPr>
+              <a:t>Auto-generated narrative section</a:t>
+            </a:r>
+          </a:p>
+        </p:txBody>
+      </p:sp>
+    </p:spTree>
+  </p:cSld>
+  <p:clrMapOvr>
+    <a:masterClrMapping/>
+  </p:clrMapOvr>
+</p:sld>
+</file>
+
+<file path=ppt/slides/slide21.xml><?xml version="1.0" encoding="utf-8"?>
+<p:sld xmlns:a="http://schemas.openxmlformats.org/drawingml/2006/main" xmlns:p="http://schemas.openxmlformats.org/presentationml/2006/main" xmlns:r="http://schemas.openxmlformats.org/officeDocument/2006/relationships">
+  <p:cSld>
+    <p:bg>
+      <p:bgPr>
+        <a:solidFill>
+          <a:srgbClr val="0F172A"/>
+        </a:solidFill>
+        <a:effectLst/>
+      </p:bgPr>
+    </p:bg>
+    <p:spTree>
+      <p:nvGrpSpPr>
+        <p:cNvPr id="1" name=""/>
+        <p:cNvGrpSpPr/>
+        <p:nvPr/>
+      </p:nvGrpSpPr>
+      <p:grpSpPr/>
+      <p:sp>
+        <p:nvSpPr>
+          <p:cNvPr id="2" name="Rounded Rectangle 1"/>
+          <p:cNvSpPr/>
+          <p:nvPr/>
+        </p:nvSpPr>
+        <p:spPr>
+          <a:xfrm>
+            <a:off x="457200" y="457200"/>
+            <a:ext cx="11277295" cy="5943600"/>
+          </a:xfrm>
+          <a:prstGeom prst="roundRect">
+            <a:avLst>
+              <a:gd name="adj" fmla="val 769"/>
+            </a:avLst>
+          </a:prstGeom>
+          <a:solidFill>
+            <a:srgbClr val="1E293B"/>
+          </a:solidFill>
+          <a:ln>
+            <a:noFill/>
+          </a:ln>
+        </p:spPr>
+        <p:style>
+          <a:lnRef idx="1">
+            <a:schemeClr val="accent1"/>
+          </a:lnRef>
+          <a:fillRef idx="3">
+            <a:schemeClr val="accent1"/>
+          </a:fillRef>
+          <a:effectRef idx="2">
+            <a:schemeClr val="accent1"/>
+          </a:effectRef>
+          <a:fontRef idx="minor">
+            <a:schemeClr val="lt1"/>
+          </a:fontRef>
+        </p:style>
+        <p:txBody>
+          <a:bodyPr rtlCol="0" anchor="ctr"/>
+          <a:lstStyle/>
+          <a:p>
+            <a:pPr algn="ctr"/>
+          </a:p>
+        </p:txBody>
+      </p:sp>
+      <p:sp>
+        <p:nvSpPr>
+          <p:cNvPr id="3" name="Rectangle 2"/>
+          <p:cNvSpPr/>
+          <p:nvPr/>
+        </p:nvSpPr>
+        <p:spPr>
+          <a:xfrm>
+            <a:off x="457200" y="457200"/>
+            <a:ext cx="11277295" cy="45720"/>
+          </a:xfrm>
+          <a:prstGeom prst="rect">
+            <a:avLst/>
+          </a:prstGeom>
+          <a:solidFill>
+            <a:srgbClr val="3B82F6"/>
+          </a:solidFill>
+          <a:ln>
+            <a:noFill/>
+          </a:ln>
+        </p:spPr>
+        <p:style>
+          <a:lnRef idx="1">
+            <a:schemeClr val="accent1"/>
+          </a:lnRef>
+          <a:fillRef idx="3">
+            <a:schemeClr val="accent1"/>
+          </a:fillRef>
+          <a:effectRef idx="2">
+            <a:schemeClr val="accent1"/>
+          </a:effectRef>
+          <a:fontRef idx="minor">
+            <a:schemeClr val="lt1"/>
+          </a:fontRef>
+        </p:style>
+        <p:txBody>
+          <a:bodyPr rtlCol="0" anchor="ctr"/>
+          <a:lstStyle/>
+          <a:p>
+            <a:pPr algn="ctr"/>
+          </a:p>
+        </p:txBody>
+      </p:sp>
+      <p:sp>
+        <p:nvSpPr>
+          <p:cNvPr id="4" name="TextBox 3"/>
+          <p:cNvSpPr txBox="1"/>
+          <p:nvPr/>
+        </p:nvSpPr>
+        <p:spPr>
+          <a:xfrm>
+            <a:off x="10637215" y="640080"/>
+            <a:ext cx="914400" cy="228600"/>
+          </a:xfrm>
+          <a:prstGeom prst="rect">
+            <a:avLst/>
+          </a:prstGeom>
+          <a:noFill/>
+        </p:spPr>
+        <p:txBody>
+          <a:bodyPr wrap="square" lIns="0" tIns="0" rIns="0" bIns="0">
+            <a:spAutoFit/>
+          </a:bodyPr>
+          <a:lstStyle/>
+          <a:p>
+            <a:pPr algn="r"/>
+            <a:r>
+              <a:rPr sz="1100" b="1" i="0">
+                <a:solidFill>
+                  <a:srgbClr val="94A3B8"/>
+                </a:solidFill>
+                <a:latin typeface="Calibri"/>
+              </a:rPr>
+              <a:t>Page 2/3</a:t>
+            </a:r>
+          </a:p>
+        </p:txBody>
+      </p:sp>
+      <p:sp>
+        <p:nvSpPr>
+          <p:cNvPr id="5" name="TextBox 4"/>
+          <p:cNvSpPr txBox="1"/>
+          <p:nvPr/>
+        </p:nvSpPr>
+        <p:spPr>
+          <a:xfrm>
+            <a:off x="640080" y="640080"/>
+            <a:ext cx="9997135" cy="320040"/>
+          </a:xfrm>
+          <a:prstGeom prst="rect">
+            <a:avLst/>
+          </a:prstGeom>
+          <a:noFill/>
+        </p:spPr>
+        <p:txBody>
+          <a:bodyPr wrap="square" lIns="0" tIns="0" rIns="0" bIns="0">
+            <a:spAutoFit/>
+          </a:bodyPr>
+          <a:lstStyle/>
+          <a:p>
+            <a:pPr algn="l"/>
+            <a:r>
+              <a:rPr sz="2000" b="1" i="0">
+                <a:solidFill>
+                  <a:srgbClr val="F8FAFC"/>
+                </a:solidFill>
+                <a:latin typeface="Calibri Light"/>
+              </a:rPr>
+              <a:t>Executive Narrative - Auto Paginated</a:t>
+            </a:r>
+          </a:p>
+        </p:txBody>
+      </p:sp>
+      <p:sp>
+        <p:nvSpPr>
+          <p:cNvPr id="6" name="TextBox 5"/>
+          <p:cNvSpPr txBox="1"/>
+          <p:nvPr/>
+        </p:nvSpPr>
+        <p:spPr>
+          <a:xfrm>
+            <a:off x="640080" y="960119"/>
+            <a:ext cx="10911535" cy="256032"/>
+          </a:xfrm>
+          <a:prstGeom prst="rect">
+            <a:avLst/>
+          </a:prstGeom>
+          <a:noFill/>
+        </p:spPr>
+        <p:txBody>
+          <a:bodyPr wrap="square" lIns="0" tIns="0" rIns="0" bIns="0">
+            <a:spAutoFit/>
+          </a:bodyPr>
+          <a:lstStyle/>
+          <a:p>
+            <a:pPr algn="l"/>
+            <a:r>
+              <a:rPr sz="1100" b="0" i="0">
+                <a:solidFill>
+                  <a:srgbClr val="94A3B8"/>
+                </a:solidFill>
+                <a:latin typeface="Calibri"/>
+              </a:rPr>
+              <a:t>Long text automatically split into multiple slides.</a:t>
+            </a:r>
+          </a:p>
+        </p:txBody>
+      </p:sp>
+      <p:sp>
+        <p:nvSpPr>
+          <p:cNvPr id="7" name="Rounded Rectangle 6"/>
+          <p:cNvSpPr/>
+          <p:nvPr/>
+        </p:nvSpPr>
+        <p:spPr>
+          <a:xfrm>
+            <a:off x="640080" y="1252728"/>
+            <a:ext cx="7485680" cy="4965192"/>
+          </a:xfrm>
+          <a:prstGeom prst="roundRect">
+            <a:avLst>
+              <a:gd name="adj" fmla="val 552"/>
+            </a:avLst>
+          </a:prstGeom>
+          <a:solidFill>
+            <a:srgbClr val="0F172A"/>
+          </a:solidFill>
+          <a:ln>
+            <a:noFill/>
+          </a:ln>
+        </p:spPr>
+        <p:style>
+          <a:lnRef idx="1">
+            <a:schemeClr val="accent1"/>
+          </a:lnRef>
+          <a:fillRef idx="3">
+            <a:schemeClr val="accent1"/>
+          </a:fillRef>
+          <a:effectRef idx="2">
+            <a:schemeClr val="accent1"/>
+          </a:effectRef>
+          <a:fontRef idx="minor">
+            <a:schemeClr val="lt1"/>
+          </a:fontRef>
+        </p:style>
+        <p:txBody>
+          <a:bodyPr rtlCol="0" anchor="ctr"/>
+          <a:lstStyle/>
+          <a:p>
+            <a:pPr algn="ctr"/>
+          </a:p>
+        </p:txBody>
+      </p:sp>
+      <p:sp>
+        <p:nvSpPr>
+          <p:cNvPr id="8" name="TextBox 7"/>
+          <p:cNvSpPr txBox="1"/>
+          <p:nvPr/>
+        </p:nvSpPr>
+        <p:spPr>
+          <a:xfrm>
+            <a:off x="768096" y="1362455"/>
+            <a:ext cx="7229648" cy="4745736"/>
+          </a:xfrm>
+          <a:prstGeom prst="rect">
+            <a:avLst/>
+          </a:prstGeom>
+          <a:noFill/>
+        </p:spPr>
+        <p:txBody>
+          <a:bodyPr wrap="square" lIns="0" tIns="0" rIns="0" bIns="0">
+            <a:spAutoFit/>
+          </a:bodyPr>
+          <a:lstStyle/>
+          <a:p>
+            <a:pPr algn="l"/>
+            <a:r>
+              <a:rPr sz="1400" b="0" i="0">
+                <a:solidFill>
+                  <a:srgbClr val="CBD5E1"/>
+                </a:solidFill>
+                <a:latin typeface="Calibri"/>
+              </a:rPr>
+              <a:t>Execution improved in the operating model. Onboarding cycle time dropped 19% after workflow simplification and proactive implementation playbooks. At the same time, migration volume increased support load, highlighting where product instrumentation and self-service diagnostics were still too shallow.
+(continued on next slide)</a:t>
+            </a:r>
+          </a:p>
+        </p:txBody>
+      </p:sp>
+      <p:sp>
+        <p:nvSpPr>
+          <p:cNvPr id="9" name="Rounded Rectangle 8"/>
+          <p:cNvSpPr/>
+          <p:nvPr/>
+        </p:nvSpPr>
+        <p:spPr>
+          <a:xfrm>
+            <a:off x="8144048" y="1252728"/>
+            <a:ext cx="3242974" cy="4965192"/>
+          </a:xfrm>
+          <a:prstGeom prst="roundRect">
+            <a:avLst>
+              <a:gd name="adj" fmla="val 844"/>
+            </a:avLst>
+          </a:prstGeom>
+          <a:solidFill>
+            <a:srgbClr val="334155"/>
+          </a:solidFill>
+          <a:ln>
+            <a:noFill/>
+          </a:ln>
+        </p:spPr>
+        <p:style>
+          <a:lnRef idx="1">
+            <a:schemeClr val="accent1"/>
+          </a:lnRef>
+          <a:fillRef idx="3">
+            <a:schemeClr val="accent1"/>
+          </a:fillRef>
+          <a:effectRef idx="2">
+            <a:schemeClr val="accent1"/>
+          </a:effectRef>
+          <a:fontRef idx="minor">
+            <a:schemeClr val="lt1"/>
+          </a:fontRef>
+        </p:style>
+        <p:txBody>
+          <a:bodyPr rtlCol="0" anchor="ctr"/>
+          <a:lstStyle/>
+          <a:p>
+            <a:pPr algn="ctr"/>
+          </a:p>
+        </p:txBody>
+      </p:sp>
+      <p:sp>
+        <p:nvSpPr>
+          <p:cNvPr id="10" name="TextBox 9"/>
+          <p:cNvSpPr txBox="1"/>
+          <p:nvPr/>
+        </p:nvSpPr>
+        <p:spPr>
+          <a:xfrm>
+            <a:off x="8253776" y="1344168"/>
+            <a:ext cx="3023518" cy="228600"/>
+          </a:xfrm>
+          <a:prstGeom prst="rect">
+            <a:avLst/>
+          </a:prstGeom>
+          <a:noFill/>
+        </p:spPr>
+        <p:txBody>
+          <a:bodyPr wrap="square" lIns="0" tIns="0" rIns="0" bIns="0">
+            <a:spAutoFit/>
+          </a:bodyPr>
+          <a:lstStyle/>
+          <a:p>
+            <a:pPr algn="l"/>
+            <a:r>
+              <a:rPr sz="1100" b="1" i="0">
+                <a:solidFill>
+                  <a:srgbClr val="F8FAFC"/>
+                </a:solidFill>
+                <a:latin typeface="Calibri"/>
+              </a:rPr>
+              <a:t>Steering Notes</a:t>
+            </a:r>
+          </a:p>
+        </p:txBody>
+      </p:sp>
+      <p:sp>
+        <p:nvSpPr>
+          <p:cNvPr id="11" name="TextBox 10"/>
+          <p:cNvSpPr txBox="1"/>
+          <p:nvPr/>
+        </p:nvSpPr>
+        <p:spPr>
+          <a:xfrm>
+            <a:off x="8253776" y="1563624"/>
+            <a:ext cx="3023518" cy="3277026"/>
+          </a:xfrm>
+          <a:prstGeom prst="rect">
+            <a:avLst/>
+          </a:prstGeom>
+          <a:noFill/>
+        </p:spPr>
+        <p:txBody>
+          <a:bodyPr wrap="square" lIns="0" tIns="0" rIns="0" bIns="0">
+            <a:spAutoFit/>
+          </a:bodyPr>
+          <a:lstStyle/>
+          <a:p>
+            <a:pPr algn="l"/>
+            <a:r>
+              <a:rPr sz="1100" b="0" i="0">
+                <a:solidFill>
+                  <a:srgbClr val="CBD5E1"/>
+                </a:solidFill>
+                <a:latin typeface="Calibri"/>
+              </a:rPr>
+              <a:t>- Watch enterprise concentration
+- Keep onboarding gains sticky
+- Fund observability upgrades
+- Track p95 latency weekly</a:t>
+            </a:r>
+          </a:p>
+        </p:txBody>
+      </p:sp>
+      <p:sp>
+        <p:nvSpPr>
+          <p:cNvPr id="12" name="TextBox 11"/>
+          <p:cNvSpPr txBox="1"/>
+          <p:nvPr/>
+        </p:nvSpPr>
+        <p:spPr>
+          <a:xfrm>
+            <a:off x="8253776" y="5577840"/>
+            <a:ext cx="3023518" cy="530352"/>
+          </a:xfrm>
+          <a:prstGeom prst="rect">
+            <a:avLst/>
+          </a:prstGeom>
+          <a:noFill/>
+        </p:spPr>
+        <p:txBody>
+          <a:bodyPr wrap="square" lIns="0" tIns="0" rIns="0" bIns="0">
+            <a:spAutoFit/>
+          </a:bodyPr>
+          <a:lstStyle/>
+          <a:p>
+            <a:pPr algn="l"/>
+            <a:r>
+              <a:rPr sz="1100" b="1" i="0">
+                <a:solidFill>
+                  <a:srgbClr val="3B82F6"/>
+                </a:solidFill>
+                <a:latin typeface="Calibri"/>
+              </a:rPr>
+              <a:t>Auto-generated narrative section</a:t>
+            </a:r>
+          </a:p>
+        </p:txBody>
+      </p:sp>
+    </p:spTree>
+  </p:cSld>
+  <p:clrMapOvr>
+    <a:masterClrMapping/>
+  </p:clrMapOvr>
+</p:sld>
+</file>
+
+<file path=ppt/slides/slide22.xml><?xml version="1.0" encoding="utf-8"?>
+<p:sld xmlns:a="http://schemas.openxmlformats.org/drawingml/2006/main" xmlns:p="http://schemas.openxmlformats.org/presentationml/2006/main" xmlns:r="http://schemas.openxmlformats.org/officeDocument/2006/relationships">
+  <p:cSld>
+    <p:bg>
+      <p:bgPr>
+        <a:solidFill>
+          <a:srgbClr val="0F172A"/>
+        </a:solidFill>
+        <a:effectLst/>
+      </p:bgPr>
+    </p:bg>
+    <p:spTree>
+      <p:nvGrpSpPr>
+        <p:cNvPr id="1" name=""/>
+        <p:cNvGrpSpPr/>
+        <p:nvPr/>
+      </p:nvGrpSpPr>
+      <p:grpSpPr/>
+      <p:sp>
+        <p:nvSpPr>
+          <p:cNvPr id="2" name="Rounded Rectangle 1"/>
+          <p:cNvSpPr/>
+          <p:nvPr/>
+        </p:nvSpPr>
+        <p:spPr>
+          <a:xfrm>
+            <a:off x="457200" y="457200"/>
+            <a:ext cx="11277295" cy="5943600"/>
+          </a:xfrm>
+          <a:prstGeom prst="roundRect">
+            <a:avLst>
+              <a:gd name="adj" fmla="val 769"/>
+            </a:avLst>
+          </a:prstGeom>
+          <a:solidFill>
+            <a:srgbClr val="1E293B"/>
+          </a:solidFill>
+          <a:ln>
+            <a:noFill/>
+          </a:ln>
+        </p:spPr>
+        <p:style>
+          <a:lnRef idx="1">
+            <a:schemeClr val="accent1"/>
+          </a:lnRef>
+          <a:fillRef idx="3">
+            <a:schemeClr val="accent1"/>
+          </a:fillRef>
+          <a:effectRef idx="2">
+            <a:schemeClr val="accent1"/>
+          </a:effectRef>
+          <a:fontRef idx="minor">
+            <a:schemeClr val="lt1"/>
+          </a:fontRef>
+        </p:style>
+        <p:txBody>
+          <a:bodyPr rtlCol="0" anchor="ctr"/>
+          <a:lstStyle/>
+          <a:p>
+            <a:pPr algn="ctr"/>
+          </a:p>
+        </p:txBody>
+      </p:sp>
+      <p:sp>
+        <p:nvSpPr>
+          <p:cNvPr id="3" name="Rectangle 2"/>
+          <p:cNvSpPr/>
+          <p:nvPr/>
+        </p:nvSpPr>
+        <p:spPr>
+          <a:xfrm>
+            <a:off x="457200" y="457200"/>
+            <a:ext cx="11277295" cy="45720"/>
+          </a:xfrm>
+          <a:prstGeom prst="rect">
+            <a:avLst/>
+          </a:prstGeom>
+          <a:solidFill>
+            <a:srgbClr val="3B82F6"/>
+          </a:solidFill>
+          <a:ln>
+            <a:noFill/>
+          </a:ln>
+        </p:spPr>
+        <p:style>
+          <a:lnRef idx="1">
+            <a:schemeClr val="accent1"/>
+          </a:lnRef>
+          <a:fillRef idx="3">
+            <a:schemeClr val="accent1"/>
+          </a:fillRef>
+          <a:effectRef idx="2">
+            <a:schemeClr val="accent1"/>
+          </a:effectRef>
+          <a:fontRef idx="minor">
+            <a:schemeClr val="lt1"/>
+          </a:fontRef>
+        </p:style>
+        <p:txBody>
+          <a:bodyPr rtlCol="0" anchor="ctr"/>
+          <a:lstStyle/>
+          <a:p>
+            <a:pPr algn="ctr"/>
+          </a:p>
+        </p:txBody>
+      </p:sp>
+      <p:sp>
+        <p:nvSpPr>
+          <p:cNvPr id="4" name="TextBox 3"/>
+          <p:cNvSpPr txBox="1"/>
+          <p:nvPr/>
+        </p:nvSpPr>
+        <p:spPr>
+          <a:xfrm>
+            <a:off x="10637215" y="640080"/>
+            <a:ext cx="914400" cy="228600"/>
+          </a:xfrm>
+          <a:prstGeom prst="rect">
+            <a:avLst/>
+          </a:prstGeom>
+          <a:noFill/>
+        </p:spPr>
+        <p:txBody>
+          <a:bodyPr wrap="square" lIns="0" tIns="0" rIns="0" bIns="0">
+            <a:spAutoFit/>
+          </a:bodyPr>
+          <a:lstStyle/>
+          <a:p>
+            <a:pPr algn="r"/>
+            <a:r>
+              <a:rPr sz="1100" b="1" i="0">
+                <a:solidFill>
+                  <a:srgbClr val="94A3B8"/>
+                </a:solidFill>
+                <a:latin typeface="Calibri"/>
+              </a:rPr>
+              <a:t>Page 3/3</a:t>
+            </a:r>
+          </a:p>
+        </p:txBody>
+      </p:sp>
+      <p:sp>
+        <p:nvSpPr>
+          <p:cNvPr id="5" name="TextBox 4"/>
+          <p:cNvSpPr txBox="1"/>
+          <p:nvPr/>
+        </p:nvSpPr>
+        <p:spPr>
+          <a:xfrm>
+            <a:off x="640080" y="640080"/>
+            <a:ext cx="9997135" cy="320040"/>
+          </a:xfrm>
+          <a:prstGeom prst="rect">
+            <a:avLst/>
+          </a:prstGeom>
+          <a:noFill/>
+        </p:spPr>
+        <p:txBody>
+          <a:bodyPr wrap="square" lIns="0" tIns="0" rIns="0" bIns="0">
+            <a:spAutoFit/>
+          </a:bodyPr>
+          <a:lstStyle/>
+          <a:p>
+            <a:pPr algn="l"/>
+            <a:r>
+              <a:rPr sz="2000" b="1" i="0">
+                <a:solidFill>
+                  <a:srgbClr val="F8FAFC"/>
+                </a:solidFill>
+                <a:latin typeface="Calibri Light"/>
+              </a:rPr>
+              <a:t>Executive Narrative - Auto Paginated</a:t>
+            </a:r>
+          </a:p>
+        </p:txBody>
+      </p:sp>
+      <p:sp>
+        <p:nvSpPr>
+          <p:cNvPr id="6" name="TextBox 5"/>
+          <p:cNvSpPr txBox="1"/>
+          <p:nvPr/>
+        </p:nvSpPr>
+        <p:spPr>
+          <a:xfrm>
+            <a:off x="640080" y="960119"/>
+            <a:ext cx="10911535" cy="256032"/>
+          </a:xfrm>
+          <a:prstGeom prst="rect">
+            <a:avLst/>
+          </a:prstGeom>
+          <a:noFill/>
+        </p:spPr>
+        <p:txBody>
+          <a:bodyPr wrap="square" lIns="0" tIns="0" rIns="0" bIns="0">
+            <a:spAutoFit/>
+          </a:bodyPr>
+          <a:lstStyle/>
+          <a:p>
+            <a:pPr algn="l"/>
+            <a:r>
+              <a:rPr sz="1100" b="0" i="0">
+                <a:solidFill>
+                  <a:srgbClr val="94A3B8"/>
+                </a:solidFill>
+                <a:latin typeface="Calibri"/>
+              </a:rPr>
+              <a:t>Long text automatically split into multiple slides.</a:t>
+            </a:r>
+          </a:p>
+        </p:txBody>
+      </p:sp>
+      <p:sp>
+        <p:nvSpPr>
+          <p:cNvPr id="7" name="Rounded Rectangle 6"/>
+          <p:cNvSpPr/>
+          <p:nvPr/>
+        </p:nvSpPr>
+        <p:spPr>
+          <a:xfrm>
+            <a:off x="640080" y="1252728"/>
+            <a:ext cx="7485680" cy="4965192"/>
+          </a:xfrm>
+          <a:prstGeom prst="roundRect">
+            <a:avLst>
+              <a:gd name="adj" fmla="val 552"/>
+            </a:avLst>
+          </a:prstGeom>
+          <a:solidFill>
+            <a:srgbClr val="0F172A"/>
+          </a:solidFill>
+          <a:ln>
+            <a:noFill/>
+          </a:ln>
+        </p:spPr>
+        <p:style>
+          <a:lnRef idx="1">
+            <a:schemeClr val="accent1"/>
+          </a:lnRef>
+          <a:fillRef idx="3">
+            <a:schemeClr val="accent1"/>
+          </a:fillRef>
+          <a:effectRef idx="2">
+            <a:schemeClr val="accent1"/>
+          </a:effectRef>
+          <a:fontRef idx="minor">
+            <a:schemeClr val="lt1"/>
+          </a:fontRef>
+        </p:style>
+        <p:txBody>
+          <a:bodyPr rtlCol="0" anchor="ctr"/>
+          <a:lstStyle/>
+          <a:p>
+            <a:pPr algn="ctr"/>
+          </a:p>
+        </p:txBody>
+      </p:sp>
+      <p:sp>
+        <p:nvSpPr>
+          <p:cNvPr id="8" name="TextBox 7"/>
+          <p:cNvSpPr txBox="1"/>
+          <p:nvPr/>
+        </p:nvSpPr>
+        <p:spPr>
+          <a:xfrm>
+            <a:off x="768096" y="1362455"/>
+            <a:ext cx="7229648" cy="4745736"/>
+          </a:xfrm>
+          <a:prstGeom prst="rect">
+            <a:avLst/>
+          </a:prstGeom>
+          <a:noFill/>
+        </p:spPr>
+        <p:txBody>
+          <a:bodyPr wrap="square" lIns="0" tIns="0" rIns="0" bIns="0">
+            <a:spAutoFit/>
+          </a:bodyPr>
+          <a:lstStyle/>
+          <a:p>
+            <a:pPr algn="l"/>
+            <a:r>
+              <a:rPr sz="1400" b="0" i="0">
+                <a:solidFill>
+                  <a:srgbClr val="CBD5E1"/>
+                </a:solidFill>
+                <a:latin typeface="Calibri"/>
+              </a:rPr>
+              <a:t>Financially, gross margin improved by 2.3 points due to infrastructure right-sizing and contract renegotiation in third-party services. This gain is expected to partially normalize in Q3 while regional failover hardening and observability upgrades are in flight.
+The second-half plan focuses on durable retention drivers, expansion motion enablement, and service-quality stabilization. Decision velocity and cross-functional accountability are now the central execution constraints, not strategy clarity.</a:t>
+            </a:r>
+          </a:p>
+        </p:txBody>
+      </p:sp>
+      <p:sp>
+        <p:nvSpPr>
+          <p:cNvPr id="9" name="Rounded Rectangle 8"/>
+          <p:cNvSpPr/>
+          <p:nvPr/>
+        </p:nvSpPr>
+        <p:spPr>
+          <a:xfrm>
+            <a:off x="8144048" y="1252728"/>
+            <a:ext cx="3242974" cy="4965192"/>
+          </a:xfrm>
+          <a:prstGeom prst="roundRect">
+            <a:avLst>
+              <a:gd name="adj" fmla="val 844"/>
+            </a:avLst>
+          </a:prstGeom>
+          <a:solidFill>
+            <a:srgbClr val="334155"/>
+          </a:solidFill>
+          <a:ln>
+            <a:noFill/>
+          </a:ln>
+        </p:spPr>
+        <p:style>
+          <a:lnRef idx="1">
+            <a:schemeClr val="accent1"/>
+          </a:lnRef>
+          <a:fillRef idx="3">
+            <a:schemeClr val="accent1"/>
+          </a:fillRef>
+          <a:effectRef idx="2">
+            <a:schemeClr val="accent1"/>
+          </a:effectRef>
+          <a:fontRef idx="minor">
+            <a:schemeClr val="lt1"/>
+          </a:fontRef>
+        </p:style>
+        <p:txBody>
+          <a:bodyPr rtlCol="0" anchor="ctr"/>
+          <a:lstStyle/>
+          <a:p>
+            <a:pPr algn="ctr"/>
+          </a:p>
+        </p:txBody>
+      </p:sp>
+      <p:sp>
+        <p:nvSpPr>
+          <p:cNvPr id="10" name="TextBox 9"/>
+          <p:cNvSpPr txBox="1"/>
+          <p:nvPr/>
+        </p:nvSpPr>
+        <p:spPr>
+          <a:xfrm>
+            <a:off x="8253776" y="1344168"/>
+            <a:ext cx="3023518" cy="228600"/>
+          </a:xfrm>
+          <a:prstGeom prst="rect">
+            <a:avLst/>
+          </a:prstGeom>
+          <a:noFill/>
+        </p:spPr>
+        <p:txBody>
+          <a:bodyPr wrap="square" lIns="0" tIns="0" rIns="0" bIns="0">
+            <a:spAutoFit/>
+          </a:bodyPr>
+          <a:lstStyle/>
+          <a:p>
+            <a:pPr algn="l"/>
+            <a:r>
+              <a:rPr sz="1100" b="1" i="0">
+                <a:solidFill>
+                  <a:srgbClr val="F8FAFC"/>
+                </a:solidFill>
+                <a:latin typeface="Calibri"/>
+              </a:rPr>
+              <a:t>Steering Notes</a:t>
+            </a:r>
+          </a:p>
+        </p:txBody>
+      </p:sp>
+      <p:sp>
+        <p:nvSpPr>
+          <p:cNvPr id="11" name="TextBox 10"/>
+          <p:cNvSpPr txBox="1"/>
+          <p:nvPr/>
+        </p:nvSpPr>
+        <p:spPr>
+          <a:xfrm>
+            <a:off x="8253776" y="1563624"/>
+            <a:ext cx="3023518" cy="3277026"/>
+          </a:xfrm>
+          <a:prstGeom prst="rect">
+            <a:avLst/>
+          </a:prstGeom>
+          <a:noFill/>
+        </p:spPr>
+        <p:txBody>
+          <a:bodyPr wrap="square" lIns="0" tIns="0" rIns="0" bIns="0">
+            <a:spAutoFit/>
+          </a:bodyPr>
+          <a:lstStyle/>
+          <a:p>
+            <a:pPr algn="l"/>
+            <a:r>
+              <a:rPr sz="1100" b="0" i="0">
+                <a:solidFill>
+                  <a:srgbClr val="CBD5E1"/>
+                </a:solidFill>
+                <a:latin typeface="Calibri"/>
+              </a:rPr>
+              <a:t>- Watch enterprise concentration
+- Keep onboarding gains sticky
+- Fund observability upgrades
+- Track p95 latency weekly</a:t>
+            </a:r>
+          </a:p>
+        </p:txBody>
+      </p:sp>
+      <p:sp>
+        <p:nvSpPr>
+          <p:cNvPr id="12" name="TextBox 11"/>
+          <p:cNvSpPr txBox="1"/>
+          <p:nvPr/>
+        </p:nvSpPr>
+        <p:spPr>
+          <a:xfrm>
+            <a:off x="8253776" y="5577840"/>
+            <a:ext cx="3023518" cy="530352"/>
+          </a:xfrm>
+          <a:prstGeom prst="rect">
+            <a:avLst/>
+          </a:prstGeom>
+          <a:noFill/>
+        </p:spPr>
+        <p:txBody>
+          <a:bodyPr wrap="square" lIns="0" tIns="0" rIns="0" bIns="0">
+            <a:spAutoFit/>
+          </a:bodyPr>
+          <a:lstStyle/>
+          <a:p>
+            <a:pPr algn="l"/>
+            <a:r>
+              <a:rPr sz="1100" b="1" i="0">
+                <a:solidFill>
+                  <a:srgbClr val="3B82F6"/>
+                </a:solidFill>
+                <a:latin typeface="Calibri"/>
+              </a:rPr>
+              <a:t>Auto-generated narrative section</a:t>
+            </a:r>
+          </a:p>
+        </p:txBody>
+      </p:sp>
+    </p:spTree>
+  </p:cSld>
+  <p:clrMapOvr>
+    <a:masterClrMapping/>
+  </p:clrMapOvr>
+</p:sld>
+</file>
+
+<file path=ppt/slides/slide23.xml><?xml version="1.0" encoding="utf-8"?>
+<p:sld xmlns:a="http://schemas.openxmlformats.org/drawingml/2006/main" xmlns:p="http://schemas.openxmlformats.org/presentationml/2006/main" xmlns:r="http://schemas.openxmlformats.org/officeDocument/2006/relationships">
+  <p:cSld>
+    <p:bg>
+      <p:bgPr>
+        <a:solidFill>
+          <a:srgbClr val="0F172A"/>
+        </a:solidFill>
+        <a:effectLst/>
+      </p:bgPr>
+    </p:bg>
+    <p:spTree>
+      <p:nvGrpSpPr>
+        <p:cNvPr id="1" name=""/>
+        <p:cNvGrpSpPr/>
+        <p:nvPr/>
+      </p:nvGrpSpPr>
+      <p:grpSpPr/>
+      <p:sp>
+        <p:nvSpPr>
+          <p:cNvPr id="2" name="Rectangle 1"/>
+          <p:cNvSpPr/>
+          <p:nvPr/>
+        </p:nvSpPr>
+        <p:spPr>
+          <a:xfrm>
+            <a:off x="457200" y="457200"/>
+            <a:ext cx="45720" cy="548640"/>
+          </a:xfrm>
+          <a:prstGeom prst="rect">
+            <a:avLst/>
+          </a:prstGeom>
+          <a:solidFill>
+            <a:srgbClr val="3B82F6"/>
+          </a:solidFill>
+          <a:ln>
+            <a:noFill/>
+          </a:ln>
+        </p:spPr>
+        <p:style>
+          <a:lnRef idx="1">
+            <a:schemeClr val="accent1"/>
+          </a:lnRef>
+          <a:fillRef idx="3">
+            <a:schemeClr val="accent1"/>
+          </a:fillRef>
+          <a:effectRef idx="2">
+            <a:schemeClr val="accent1"/>
+          </a:effectRef>
+          <a:fontRef idx="minor">
+            <a:schemeClr val="lt1"/>
+          </a:fontRef>
+        </p:style>
+        <p:txBody>
+          <a:bodyPr rtlCol="0" anchor="ctr"/>
+          <a:lstStyle/>
+          <a:p>
+            <a:pPr algn="ctr"/>
+          </a:p>
+        </p:txBody>
+      </p:sp>
+      <p:sp>
+        <p:nvSpPr>
+          <p:cNvPr id="3" name="TextBox 2"/>
+          <p:cNvSpPr txBox="1"/>
+          <p:nvPr/>
+        </p:nvSpPr>
+        <p:spPr>
+          <a:xfrm>
+            <a:off x="685800" y="457200"/>
+            <a:ext cx="9183319" cy="548640"/>
+          </a:xfrm>
+          <a:prstGeom prst="rect">
+            <a:avLst/>
+          </a:prstGeom>
+          <a:noFill/>
+        </p:spPr>
+        <p:txBody>
+          <a:bodyPr wrap="square" lIns="0" tIns="0" rIns="0" bIns="0">
+            <a:spAutoFit/>
+          </a:bodyPr>
+          <a:lstStyle/>
+          <a:p>
+            <a:pPr algn="l"/>
+            <a:r>
+              <a:rPr sz="2800" b="1" i="0">
+                <a:solidFill>
+                  <a:srgbClr val="F8FAFC"/>
+                </a:solidFill>
+                <a:latin typeface="Calibri Light"/>
+              </a:rPr>
+              <a:t>Theme Cascade QA</a:t>
+            </a:r>
+          </a:p>
+        </p:txBody>
+      </p:sp>
+      <p:sp>
+        <p:nvSpPr>
+          <p:cNvPr id="4" name="Rounded Rectangle 3"/>
+          <p:cNvSpPr/>
+          <p:nvPr/>
+        </p:nvSpPr>
+        <p:spPr>
+          <a:xfrm>
+            <a:off x="10051999" y="571500"/>
+            <a:ext cx="1682496" cy="320040"/>
+          </a:xfrm>
+          <a:prstGeom prst="roundRect">
+            <a:avLst>
+              <a:gd name="adj" fmla="val 50000"/>
+            </a:avLst>
+          </a:prstGeom>
+          <a:solidFill>
+            <a:srgbClr val="3B82F6"/>
+          </a:solidFill>
+          <a:ln>
+            <a:noFill/>
+          </a:ln>
+        </p:spPr>
+        <p:style>
+          <a:lnRef idx="1">
+            <a:schemeClr val="accent1"/>
+          </a:lnRef>
+          <a:fillRef idx="3">
+            <a:schemeClr val="accent1"/>
+          </a:fillRef>
+          <a:effectRef idx="2">
+            <a:schemeClr val="accent1"/>
+          </a:effectRef>
+          <a:fontRef idx="minor">
+            <a:schemeClr val="lt1"/>
+          </a:fontRef>
+        </p:style>
+        <p:txBody>
+          <a:bodyPr rtlCol="0" anchor="ctr" wrap="none"/>
+          <a:lstStyle/>
+          <a:p>
+            <a:pPr algn="ctr"/>
+            <a:r>
+              <a:rPr sz="1100" b="1">
+                <a:solidFill>
+                  <a:srgbClr val="FFFFFF"/>
+                </a:solidFill>
+                <a:latin typeface="Calibri"/>
+              </a:rPr>
+              <a:t>Section Overrides</a:t>
+            </a:r>
+          </a:p>
+        </p:txBody>
+      </p:sp>
+      <p:sp>
+        <p:nvSpPr>
+          <p:cNvPr id="5" name="Rounded Rectangle 4"/>
+          <p:cNvSpPr/>
+          <p:nvPr/>
+        </p:nvSpPr>
+        <p:spPr>
+          <a:xfrm>
+            <a:off x="457200" y="1298448"/>
+            <a:ext cx="5547207" cy="3474720"/>
+          </a:xfrm>
+          <a:prstGeom prst="roundRect">
+            <a:avLst>
+              <a:gd name="adj" fmla="val 1315"/>
+            </a:avLst>
+          </a:prstGeom>
+          <a:solidFill>
+            <a:srgbClr val="FFF7EA"/>
+          </a:solidFill>
+          <a:ln w="12700">
+            <a:solidFill>
+              <a:srgbClr val="C69768"/>
+            </a:solidFill>
+          </a:ln>
+        </p:spPr>
+        <p:style>
+          <a:lnRef idx="1">
+            <a:schemeClr val="accent1"/>
+          </a:lnRef>
+          <a:fillRef idx="3">
+            <a:schemeClr val="accent1"/>
+          </a:fillRef>
+          <a:effectRef idx="2">
+            <a:schemeClr val="accent1"/>
+          </a:effectRef>
+          <a:fontRef idx="minor">
+            <a:schemeClr val="lt1"/>
+          </a:fontRef>
+        </p:style>
+        <p:txBody>
+          <a:bodyPr rtlCol="0" anchor="ctr"/>
+          <a:lstStyle/>
+          <a:p>
+            <a:pPr algn="ctr"/>
+          </a:p>
+        </p:txBody>
+      </p:sp>
+      <p:sp>
+        <p:nvSpPr>
+          <p:cNvPr id="6" name="Rounded Rectangle 5"/>
+          <p:cNvSpPr/>
+          <p:nvPr/>
+        </p:nvSpPr>
+        <p:spPr>
+          <a:xfrm>
+            <a:off x="621792" y="1463039"/>
+            <a:ext cx="5218023" cy="1463040"/>
+          </a:xfrm>
+          <a:prstGeom prst="roundRect">
+            <a:avLst>
+              <a:gd name="adj" fmla="val 3125"/>
+            </a:avLst>
+          </a:prstGeom>
+          <a:solidFill>
+            <a:srgbClr val="FFF7EA"/>
+          </a:solidFill>
+          <a:ln>
+            <a:noFill/>
+          </a:ln>
+        </p:spPr>
+        <p:style>
+          <a:lnRef idx="1">
+            <a:schemeClr val="accent1"/>
+          </a:lnRef>
+          <a:fillRef idx="3">
+            <a:schemeClr val="accent1"/>
+          </a:fillRef>
+          <a:effectRef idx="2">
+            <a:schemeClr val="accent1"/>
+          </a:effectRef>
+          <a:fontRef idx="minor">
+            <a:schemeClr val="lt1"/>
+          </a:fontRef>
+        </p:style>
+        <p:txBody>
+          <a:bodyPr rtlCol="0" anchor="ctr"/>
+          <a:lstStyle/>
+          <a:p>
+            <a:pPr algn="ctr"/>
+          </a:p>
+        </p:txBody>
+      </p:sp>
+      <p:sp>
+        <p:nvSpPr>
+          <p:cNvPr id="7" name="Rectangle 6"/>
+          <p:cNvSpPr/>
+          <p:nvPr/>
+        </p:nvSpPr>
+        <p:spPr>
+          <a:xfrm>
+            <a:off x="621792" y="1463039"/>
+            <a:ext cx="45720" cy="1463040"/>
+          </a:xfrm>
+          <a:prstGeom prst="rect">
+            <a:avLst/>
+          </a:prstGeom>
+          <a:solidFill>
+            <a:srgbClr val="C16B29"/>
+          </a:solidFill>
+          <a:ln>
+            <a:noFill/>
+          </a:ln>
+        </p:spPr>
+        <p:style>
+          <a:lnRef idx="1">
+            <a:schemeClr val="accent1"/>
+          </a:lnRef>
+          <a:fillRef idx="3">
+            <a:schemeClr val="accent1"/>
+          </a:fillRef>
+          <a:effectRef idx="2">
+            <a:schemeClr val="accent1"/>
+          </a:effectRef>
+          <a:fontRef idx="minor">
+            <a:schemeClr val="lt1"/>
+          </a:fontRef>
+        </p:style>
+        <p:txBody>
+          <a:bodyPr rtlCol="0" anchor="ctr"/>
+          <a:lstStyle/>
+          <a:p>
+            <a:pPr algn="ctr"/>
+          </a:p>
+        </p:txBody>
+      </p:sp>
+      <p:sp>
+        <p:nvSpPr>
+          <p:cNvPr id="8" name="TextBox 7"/>
+          <p:cNvSpPr txBox="1"/>
+          <p:nvPr/>
+        </p:nvSpPr>
+        <p:spPr>
+          <a:xfrm>
+            <a:off x="850392" y="1645919"/>
+            <a:ext cx="4897983" cy="256032"/>
+          </a:xfrm>
+          <a:prstGeom prst="rect">
+            <a:avLst/>
+          </a:prstGeom>
+          <a:noFill/>
+        </p:spPr>
+        <p:txBody>
+          <a:bodyPr wrap="square" lIns="0" tIns="0" rIns="0" bIns="0">
+            <a:spAutoFit/>
+          </a:bodyPr>
+          <a:lstStyle/>
+          <a:p>
+            <a:pPr algn="l"/>
+            <a:r>
+              <a:rPr sz="1400" b="1" i="0">
+                <a:solidFill>
+                  <a:srgbClr val="4A2C16"/>
+                </a:solidFill>
+                <a:latin typeface="Calibri"/>
+              </a:rPr>
+              <a:t>Local theme patch: editorial warm palette.</a:t>
+            </a:r>
+          </a:p>
+        </p:txBody>
+      </p:sp>
+      <p:sp>
+        <p:nvSpPr>
+          <p:cNvPr id="9" name="TextBox 8"/>
+          <p:cNvSpPr txBox="1"/>
+          <p:nvPr/>
+        </p:nvSpPr>
+        <p:spPr>
+          <a:xfrm>
+            <a:off x="850392" y="2084831"/>
+            <a:ext cx="4897983" cy="658368"/>
+          </a:xfrm>
+          <a:prstGeom prst="rect">
+            <a:avLst/>
+          </a:prstGeom>
+          <a:noFill/>
+        </p:spPr>
+        <p:txBody>
+          <a:bodyPr wrap="square" lIns="0" tIns="0" rIns="0" bIns="0">
+            <a:spAutoFit/>
+          </a:bodyPr>
+          <a:lstStyle/>
+          <a:p>
+            <a:pPr algn="l"/>
+            <a:r>
+              <a:rPr sz="1400" b="0" i="0">
+                <a:solidFill>
+                  <a:srgbClr val="6F4828"/>
+                </a:solidFill>
+                <a:latin typeface="Calibri"/>
+              </a:rPr>
+              <a:t>Warm Section</a:t>
+            </a:r>
+          </a:p>
+        </p:txBody>
+      </p:sp>
+      <p:sp>
+        <p:nvSpPr>
+          <p:cNvPr id="10" name="Rounded Rectangle 9"/>
+          <p:cNvSpPr/>
+          <p:nvPr/>
+        </p:nvSpPr>
+        <p:spPr>
+          <a:xfrm>
+            <a:off x="621792" y="3035808"/>
+            <a:ext cx="5218023" cy="1371600"/>
+          </a:xfrm>
+          <a:prstGeom prst="roundRect">
+            <a:avLst>
+              <a:gd name="adj" fmla="val 3333"/>
+            </a:avLst>
+          </a:prstGeom>
+          <a:solidFill>
+            <a:srgbClr val="FFF7EA"/>
+          </a:solidFill>
+          <a:ln>
+            <a:noFill/>
+          </a:ln>
+        </p:spPr>
+        <p:style>
+          <a:lnRef idx="1">
+            <a:schemeClr val="accent1"/>
+          </a:lnRef>
+          <a:fillRef idx="3">
+            <a:schemeClr val="accent1"/>
+          </a:fillRef>
+          <a:effectRef idx="2">
+            <a:schemeClr val="accent1"/>
+          </a:effectRef>
+          <a:fontRef idx="minor">
+            <a:schemeClr val="lt1"/>
+          </a:fontRef>
+        </p:style>
+        <p:txBody>
+          <a:bodyPr rtlCol="0" anchor="ctr"/>
+          <a:lstStyle/>
+          <a:p>
+            <a:pPr algn="ctr"/>
+          </a:p>
+        </p:txBody>
+      </p:sp>
+      <p:sp>
+        <p:nvSpPr>
+          <p:cNvPr id="11" name="Rectangle 10"/>
+          <p:cNvSpPr/>
+          <p:nvPr/>
+        </p:nvSpPr>
+        <p:spPr>
+          <a:xfrm>
+            <a:off x="621792" y="3035808"/>
+            <a:ext cx="45720" cy="1371600"/>
+          </a:xfrm>
+          <a:prstGeom prst="rect">
+            <a:avLst/>
+          </a:prstGeom>
+          <a:solidFill>
+            <a:srgbClr val="C16B29"/>
+          </a:solidFill>
+          <a:ln>
+            <a:noFill/>
+          </a:ln>
+        </p:spPr>
+        <p:style>
+          <a:lnRef idx="1">
+            <a:schemeClr val="accent1"/>
+          </a:lnRef>
+          <a:fillRef idx="3">
+            <a:schemeClr val="accent1"/>
+          </a:fillRef>
+          <a:effectRef idx="2">
+            <a:schemeClr val="accent1"/>
+          </a:effectRef>
+          <a:fontRef idx="minor">
+            <a:schemeClr val="lt1"/>
+          </a:fontRef>
+        </p:style>
+        <p:txBody>
+          <a:bodyPr rtlCol="0" anchor="ctr"/>
+          <a:lstStyle/>
+          <a:p>
+            <a:pPr algn="ctr"/>
+          </a:p>
+        </p:txBody>
+      </p:sp>
+      <p:sp>
+        <p:nvSpPr>
+          <p:cNvPr id="12" name="TextBox 11"/>
+          <p:cNvSpPr txBox="1"/>
+          <p:nvPr/>
+        </p:nvSpPr>
+        <p:spPr>
+          <a:xfrm>
+            <a:off x="850392" y="3218688"/>
+            <a:ext cx="4806543" cy="228600"/>
+          </a:xfrm>
+          <a:prstGeom prst="rect">
+            <a:avLst/>
+          </a:prstGeom>
+          <a:noFill/>
+        </p:spPr>
+        <p:txBody>
+          <a:bodyPr wrap="square" lIns="0" tIns="0" rIns="0" bIns="0">
+            <a:spAutoFit/>
+          </a:bodyPr>
+          <a:lstStyle/>
+          <a:p>
+            <a:pPr algn="l"/>
+            <a:r>
+              <a:rPr sz="1100" b="0" i="0">
+                <a:solidFill>
+                  <a:srgbClr val="94A3B8"/>
+                </a:solidFill>
+                <a:latin typeface="Calibri"/>
+              </a:rPr>
+              <a:t>RETENTION</a:t>
+            </a:r>
+          </a:p>
+        </p:txBody>
+      </p:sp>
+      <p:sp>
+        <p:nvSpPr>
+          <p:cNvPr id="13" name="TextBox 12"/>
+          <p:cNvSpPr txBox="1"/>
+          <p:nvPr/>
+        </p:nvSpPr>
+        <p:spPr>
+          <a:xfrm>
+            <a:off x="850392" y="3447288"/>
+            <a:ext cx="4806543" cy="411480"/>
+          </a:xfrm>
+          <a:prstGeom prst="rect">
+            <a:avLst/>
+          </a:prstGeom>
+          <a:noFill/>
+        </p:spPr>
+        <p:txBody>
+          <a:bodyPr wrap="square" lIns="0" tIns="0" rIns="0" bIns="0">
+            <a:spAutoFit/>
+          </a:bodyPr>
+          <a:lstStyle/>
+          <a:p>
+            <a:pPr algn="l"/>
+            <a:r>
+              <a:rPr sz="2800" b="1" i="0">
+                <a:solidFill>
+                  <a:srgbClr val="4A2C16"/>
+                </a:solidFill>
+                <a:latin typeface="Calibri Light"/>
+              </a:rPr>
+              <a:t>94%</a:t>
+            </a:r>
+          </a:p>
+        </p:txBody>
+      </p:sp>
+      <p:sp>
+        <p:nvSpPr>
+          <p:cNvPr id="14" name="TextBox 13"/>
+          <p:cNvSpPr txBox="1"/>
+          <p:nvPr/>
+        </p:nvSpPr>
+        <p:spPr>
+          <a:xfrm>
+            <a:off x="850392" y="3858768"/>
+            <a:ext cx="4806543" cy="228600"/>
+          </a:xfrm>
+          <a:prstGeom prst="rect">
+            <a:avLst/>
+          </a:prstGeom>
+          <a:noFill/>
+        </p:spPr>
+        <p:txBody>
+          <a:bodyPr wrap="square" lIns="0" tIns="0" rIns="0" bIns="0">
+            <a:spAutoFit/>
+          </a:bodyPr>
+          <a:lstStyle/>
+          <a:p>
+            <a:pPr algn="l"/>
+            <a:r>
+              <a:rPr sz="1100" b="1" i="0">
+                <a:solidFill>
+                  <a:srgbClr val="22C55E"/>
+                </a:solidFill>
+                <a:latin typeface="Calibri"/>
+              </a:rPr>
+              <a:t>▲ +2pp</a:t>
+            </a:r>
+          </a:p>
+        </p:txBody>
+      </p:sp>
+      <p:sp>
+        <p:nvSpPr>
+          <p:cNvPr id="15" name="Rounded Rectangle 14"/>
+          <p:cNvSpPr/>
+          <p:nvPr/>
+        </p:nvSpPr>
+        <p:spPr>
+          <a:xfrm>
+            <a:off x="6187287" y="1298448"/>
+            <a:ext cx="5547207" cy="3474720"/>
+          </a:xfrm>
+          <a:prstGeom prst="roundRect">
+            <a:avLst>
+              <a:gd name="adj" fmla="val 1315"/>
+            </a:avLst>
+          </a:prstGeom>
+          <a:solidFill>
+            <a:srgbClr val="E8F5FF"/>
+          </a:solidFill>
+          <a:ln w="12700">
+            <a:solidFill>
+              <a:srgbClr val="7399CA"/>
+            </a:solidFill>
+          </a:ln>
+        </p:spPr>
+        <p:style>
+          <a:lnRef idx="1">
+            <a:schemeClr val="accent1"/>
+          </a:lnRef>
+          <a:fillRef idx="3">
+            <a:schemeClr val="accent1"/>
+          </a:fillRef>
+          <a:effectRef idx="2">
+            <a:schemeClr val="accent1"/>
+          </a:effectRef>
+          <a:fontRef idx="minor">
+            <a:schemeClr val="lt1"/>
+          </a:fontRef>
+        </p:style>
+        <p:txBody>
+          <a:bodyPr rtlCol="0" anchor="ctr"/>
+          <a:lstStyle/>
+          <a:p>
+            <a:pPr algn="ctr"/>
+          </a:p>
+        </p:txBody>
+      </p:sp>
+      <p:sp>
+        <p:nvSpPr>
+          <p:cNvPr id="16" name="Rounded Rectangle 15"/>
+          <p:cNvSpPr/>
+          <p:nvPr/>
+        </p:nvSpPr>
+        <p:spPr>
+          <a:xfrm>
+            <a:off x="6351879" y="1463039"/>
+            <a:ext cx="5218023" cy="1463040"/>
+          </a:xfrm>
+          <a:prstGeom prst="roundRect">
+            <a:avLst>
+              <a:gd name="adj" fmla="val 3125"/>
+            </a:avLst>
+          </a:prstGeom>
+          <a:solidFill>
+            <a:srgbClr val="E8F5FF"/>
+          </a:solidFill>
+          <a:ln>
+            <a:noFill/>
+          </a:ln>
+        </p:spPr>
+        <p:style>
+          <a:lnRef idx="1">
+            <a:schemeClr val="accent1"/>
+          </a:lnRef>
+          <a:fillRef idx="3">
+            <a:schemeClr val="accent1"/>
+          </a:fillRef>
+          <a:effectRef idx="2">
+            <a:schemeClr val="accent1"/>
+          </a:effectRef>
+          <a:fontRef idx="minor">
+            <a:schemeClr val="lt1"/>
+          </a:fontRef>
+        </p:style>
+        <p:txBody>
+          <a:bodyPr rtlCol="0" anchor="ctr"/>
+          <a:lstStyle/>
+          <a:p>
+            <a:pPr algn="ctr"/>
+          </a:p>
+        </p:txBody>
+      </p:sp>
+      <p:sp>
+        <p:nvSpPr>
+          <p:cNvPr id="17" name="Rectangle 16"/>
+          <p:cNvSpPr/>
+          <p:nvPr/>
+        </p:nvSpPr>
+        <p:spPr>
+          <a:xfrm>
+            <a:off x="6351879" y="1463039"/>
+            <a:ext cx="45720" cy="1463040"/>
+          </a:xfrm>
+          <a:prstGeom prst="rect">
+            <a:avLst/>
+          </a:prstGeom>
+          <a:solidFill>
+            <a:srgbClr val="1A63C2"/>
+          </a:solidFill>
+          <a:ln>
+            <a:noFill/>
+          </a:ln>
+        </p:spPr>
+        <p:style>
+          <a:lnRef idx="1">
+            <a:schemeClr val="accent1"/>
+          </a:lnRef>
+          <a:fillRef idx="3">
+            <a:schemeClr val="accent1"/>
+          </a:fillRef>
+          <a:effectRef idx="2">
+            <a:schemeClr val="accent1"/>
+          </a:effectRef>
+          <a:fontRef idx="minor">
+            <a:schemeClr val="lt1"/>
+          </a:fontRef>
+        </p:style>
+        <p:txBody>
+          <a:bodyPr rtlCol="0" anchor="ctr"/>
+          <a:lstStyle/>
+          <a:p>
+            <a:pPr algn="ctr"/>
+          </a:p>
+        </p:txBody>
+      </p:sp>
+      <p:sp>
+        <p:nvSpPr>
+          <p:cNvPr id="18" name="TextBox 17"/>
+          <p:cNvSpPr txBox="1"/>
+          <p:nvPr/>
+        </p:nvSpPr>
+        <p:spPr>
+          <a:xfrm>
+            <a:off x="6580479" y="1645919"/>
+            <a:ext cx="4897983" cy="256032"/>
+          </a:xfrm>
+          <a:prstGeom prst="rect">
+            <a:avLst/>
+          </a:prstGeom>
+          <a:noFill/>
+        </p:spPr>
+        <p:txBody>
+          <a:bodyPr wrap="square" lIns="0" tIns="0" rIns="0" bIns="0">
+            <a:spAutoFit/>
+          </a:bodyPr>
+          <a:lstStyle/>
+          <a:p>
+            <a:pPr algn="l"/>
+            <a:r>
+              <a:rPr sz="1400" b="1" i="0">
+                <a:solidFill>
+                  <a:srgbClr val="122B4C"/>
+                </a:solidFill>
+                <a:latin typeface="Calibri"/>
+              </a:rPr>
+              <a:t>Local theme patch: corporate blue palette.</a:t>
+            </a:r>
+          </a:p>
+        </p:txBody>
+      </p:sp>
+      <p:sp>
+        <p:nvSpPr>
+          <p:cNvPr id="19" name="TextBox 18"/>
+          <p:cNvSpPr txBox="1"/>
+          <p:nvPr/>
+        </p:nvSpPr>
+        <p:spPr>
+          <a:xfrm>
+            <a:off x="6580479" y="2084831"/>
+            <a:ext cx="4897983" cy="658368"/>
+          </a:xfrm>
+          <a:prstGeom prst="rect">
+            <a:avLst/>
+          </a:prstGeom>
+          <a:noFill/>
+        </p:spPr>
+        <p:txBody>
+          <a:bodyPr wrap="square" lIns="0" tIns="0" rIns="0" bIns="0">
+            <a:spAutoFit/>
+          </a:bodyPr>
+          <a:lstStyle/>
+          <a:p>
+            <a:pPr algn="l"/>
+            <a:r>
+              <a:rPr sz="1400" b="0" i="0">
+                <a:solidFill>
+                  <a:srgbClr val="2F4D74"/>
+                </a:solidFill>
+                <a:latin typeface="Calibri"/>
+              </a:rPr>
+              <a:t>Cool Section</a:t>
+            </a:r>
+          </a:p>
+        </p:txBody>
+      </p:sp>
+      <p:sp>
+        <p:nvSpPr>
+          <p:cNvPr id="20" name="Rounded Rectangle 19"/>
+          <p:cNvSpPr/>
+          <p:nvPr/>
+        </p:nvSpPr>
+        <p:spPr>
+          <a:xfrm>
+            <a:off x="6351879" y="3035808"/>
+            <a:ext cx="5218023" cy="1371600"/>
+          </a:xfrm>
+          <a:prstGeom prst="roundRect">
+            <a:avLst>
+              <a:gd name="adj" fmla="val 3333"/>
+            </a:avLst>
+          </a:prstGeom>
+          <a:solidFill>
+            <a:srgbClr val="E8F5FF"/>
+          </a:solidFill>
+          <a:ln>
+            <a:noFill/>
+          </a:ln>
+        </p:spPr>
+        <p:style>
+          <a:lnRef idx="1">
+            <a:schemeClr val="accent1"/>
+          </a:lnRef>
+          <a:fillRef idx="3">
+            <a:schemeClr val="accent1"/>
+          </a:fillRef>
+          <a:effectRef idx="2">
+            <a:schemeClr val="accent1"/>
+          </a:effectRef>
+          <a:fontRef idx="minor">
+            <a:schemeClr val="lt1"/>
+          </a:fontRef>
+        </p:style>
+        <p:txBody>
+          <a:bodyPr rtlCol="0" anchor="ctr"/>
+          <a:lstStyle/>
+          <a:p>
+            <a:pPr algn="ctr"/>
+          </a:p>
+        </p:txBody>
+      </p:sp>
+      <p:sp>
+        <p:nvSpPr>
+          <p:cNvPr id="21" name="Rectangle 20"/>
+          <p:cNvSpPr/>
+          <p:nvPr/>
+        </p:nvSpPr>
+        <p:spPr>
+          <a:xfrm>
+            <a:off x="6351879" y="3035808"/>
+            <a:ext cx="45720" cy="1371600"/>
+          </a:xfrm>
+          <a:prstGeom prst="rect">
+            <a:avLst/>
+          </a:prstGeom>
+          <a:solidFill>
+            <a:srgbClr val="1A63C2"/>
+          </a:solidFill>
+          <a:ln>
+            <a:noFill/>
+          </a:ln>
+        </p:spPr>
+        <p:style>
+          <a:lnRef idx="1">
+            <a:schemeClr val="accent1"/>
+          </a:lnRef>
+          <a:fillRef idx="3">
+            <a:schemeClr val="accent1"/>
+          </a:fillRef>
+          <a:effectRef idx="2">
+            <a:schemeClr val="accent1"/>
+          </a:effectRef>
+          <a:fontRef idx="minor">
+            <a:schemeClr val="lt1"/>
+          </a:fontRef>
+        </p:style>
+        <p:txBody>
+          <a:bodyPr rtlCol="0" anchor="ctr"/>
+          <a:lstStyle/>
+          <a:p>
+            <a:pPr algn="ctr"/>
+          </a:p>
+        </p:txBody>
+      </p:sp>
+      <p:sp>
+        <p:nvSpPr>
+          <p:cNvPr id="22" name="TextBox 21"/>
+          <p:cNvSpPr txBox="1"/>
+          <p:nvPr/>
+        </p:nvSpPr>
+        <p:spPr>
+          <a:xfrm>
+            <a:off x="6580479" y="3218688"/>
+            <a:ext cx="4806543" cy="228600"/>
+          </a:xfrm>
+          <a:prstGeom prst="rect">
+            <a:avLst/>
+          </a:prstGeom>
+          <a:noFill/>
+        </p:spPr>
+        <p:txBody>
+          <a:bodyPr wrap="square" lIns="0" tIns="0" rIns="0" bIns="0">
+            <a:spAutoFit/>
+          </a:bodyPr>
+          <a:lstStyle/>
+          <a:p>
+            <a:pPr algn="l"/>
+            <a:r>
+              <a:rPr sz="1100" b="0" i="0">
+                <a:solidFill>
+                  <a:srgbClr val="94A3B8"/>
+                </a:solidFill>
+                <a:latin typeface="Calibri"/>
+              </a:rPr>
+              <a:t>UPTIME</a:t>
+            </a:r>
+          </a:p>
+        </p:txBody>
+      </p:sp>
+      <p:sp>
+        <p:nvSpPr>
+          <p:cNvPr id="23" name="TextBox 22"/>
+          <p:cNvSpPr txBox="1"/>
+          <p:nvPr/>
+        </p:nvSpPr>
+        <p:spPr>
+          <a:xfrm>
+            <a:off x="6580479" y="3447288"/>
+            <a:ext cx="4806543" cy="411480"/>
+          </a:xfrm>
+          <a:prstGeom prst="rect">
+            <a:avLst/>
+          </a:prstGeom>
+          <a:noFill/>
+        </p:spPr>
+        <p:txBody>
+          <a:bodyPr wrap="square" lIns="0" tIns="0" rIns="0" bIns="0">
+            <a:spAutoFit/>
+          </a:bodyPr>
+          <a:lstStyle/>
+          <a:p>
+            <a:pPr algn="l"/>
+            <a:r>
+              <a:rPr sz="2800" b="1" i="0">
+                <a:solidFill>
+                  <a:srgbClr val="122B4C"/>
+                </a:solidFill>
+                <a:latin typeface="Calibri Light"/>
+              </a:rPr>
+              <a:t>99.97%</a:t>
+            </a:r>
+          </a:p>
+        </p:txBody>
+      </p:sp>
+      <p:sp>
+        <p:nvSpPr>
+          <p:cNvPr id="24" name="TextBox 23"/>
+          <p:cNvSpPr txBox="1"/>
+          <p:nvPr/>
+        </p:nvSpPr>
+        <p:spPr>
+          <a:xfrm>
+            <a:off x="6580479" y="3858768"/>
+            <a:ext cx="4806543" cy="228600"/>
+          </a:xfrm>
+          <a:prstGeom prst="rect">
+            <a:avLst/>
+          </a:prstGeom>
+          <a:noFill/>
+        </p:spPr>
+        <p:txBody>
+          <a:bodyPr wrap="square" lIns="0" tIns="0" rIns="0" bIns="0">
+            <a:spAutoFit/>
+          </a:bodyPr>
+          <a:lstStyle/>
+          <a:p>
+            <a:pPr algn="l"/>
+            <a:r>
+              <a:rPr sz="1100" b="1" i="0">
+                <a:solidFill>
+                  <a:srgbClr val="22C55E"/>
+                </a:solidFill>
+                <a:latin typeface="Calibri"/>
+              </a:rPr>
+              <a:t>▲ +0.04pp</a:t>
+            </a:r>
+          </a:p>
+        </p:txBody>
+      </p:sp>
+      <p:sp>
+        <p:nvSpPr>
+          <p:cNvPr id="25" name="Rounded Rectangle 24"/>
+          <p:cNvSpPr/>
+          <p:nvPr/>
+        </p:nvSpPr>
+        <p:spPr>
+          <a:xfrm>
+            <a:off x="457200" y="5138928"/>
+            <a:ext cx="11277295" cy="960120"/>
+          </a:xfrm>
+          <a:prstGeom prst="roundRect">
+            <a:avLst>
+              <a:gd name="adj" fmla="val 4761"/>
+            </a:avLst>
+          </a:prstGeom>
+          <a:solidFill>
+            <a:srgbClr val="334155"/>
+          </a:solidFill>
+          <a:ln>
+            <a:noFill/>
+          </a:ln>
+        </p:spPr>
+        <p:style>
+          <a:lnRef idx="1">
+            <a:schemeClr val="accent1"/>
+          </a:lnRef>
+          <a:fillRef idx="3">
+            <a:schemeClr val="accent1"/>
+          </a:fillRef>
+          <a:effectRef idx="2">
+            <a:schemeClr val="accent1"/>
+          </a:effectRef>
+          <a:fontRef idx="minor">
+            <a:schemeClr val="lt1"/>
+          </a:fontRef>
+        </p:style>
+        <p:txBody>
+          <a:bodyPr rtlCol="0" anchor="ctr"/>
+          <a:lstStyle/>
+          <a:p>
+            <a:pPr algn="ctr"/>
+          </a:p>
+        </p:txBody>
+      </p:sp>
+      <p:sp>
+        <p:nvSpPr>
+          <p:cNvPr id="26" name="Rectangle 25"/>
+          <p:cNvSpPr/>
+          <p:nvPr/>
+        </p:nvSpPr>
+        <p:spPr>
+          <a:xfrm>
+            <a:off x="457200" y="5138928"/>
+            <a:ext cx="45720" cy="960120"/>
+          </a:xfrm>
+          <a:prstGeom prst="rect">
+            <a:avLst/>
+          </a:prstGeom>
+          <a:solidFill>
+            <a:srgbClr val="3B82F6"/>
+          </a:solidFill>
+          <a:ln>
+            <a:noFill/>
+          </a:ln>
+        </p:spPr>
+        <p:style>
+          <a:lnRef idx="1">
+            <a:schemeClr val="accent1"/>
+          </a:lnRef>
+          <a:fillRef idx="3">
+            <a:schemeClr val="accent1"/>
+          </a:fillRef>
+          <a:effectRef idx="2">
+            <a:schemeClr val="accent1"/>
+          </a:effectRef>
+          <a:fontRef idx="minor">
+            <a:schemeClr val="lt1"/>
+          </a:fontRef>
+        </p:style>
+        <p:txBody>
+          <a:bodyPr rtlCol="0" anchor="ctr"/>
+          <a:lstStyle/>
+          <a:p>
+            <a:pPr algn="ctr"/>
+          </a:p>
+        </p:txBody>
+      </p:sp>
+      <p:sp>
+        <p:nvSpPr>
+          <p:cNvPr id="27" name="TextBox 26"/>
+          <p:cNvSpPr txBox="1"/>
+          <p:nvPr/>
+        </p:nvSpPr>
+        <p:spPr>
+          <a:xfrm>
+            <a:off x="685800" y="5321808"/>
+            <a:ext cx="10957255" cy="594359"/>
+          </a:xfrm>
+          <a:prstGeom prst="rect">
+            <a:avLst/>
+          </a:prstGeom>
+          <a:noFill/>
+        </p:spPr>
+        <p:txBody>
+          <a:bodyPr wrap="square" lIns="0" tIns="0" rIns="0" bIns="0">
+            <a:spAutoFit/>
+          </a:bodyPr>
+          <a:lstStyle/>
+          <a:p>
+            <a:pPr algn="l"/>
+            <a:r>
+              <a:rPr sz="1400" b="0" i="0">
+                <a:solidFill>
+                  <a:srgbClr val="94A3B8"/>
+                </a:solidFill>
+                <a:latin typeface="Calibri"/>
+              </a:rPr>
+              <a:t>Both cards inherit the slide theme, then apply container-scoped token patches. Use this slide to check contrast, spacing, and callout consistency across local overrides.</a:t>
             </a:r>
           </a:p>
         </p:txBody>
@@ -26454,7 +29479,7 @@
             <a:avLst/>
           </a:prstGeom>
           <a:solidFill>
-            <a:srgbClr val="3B82F6"/>
+            <a:srgbClr val="2563EB"/>
           </a:solidFill>
           <a:ln>
             <a:noFill/>
@@ -26592,7 +29617,7 @@
             <a:avLst/>
           </a:prstGeom>
           <a:solidFill>
-            <a:srgbClr val="3B82F6"/>
+            <a:srgbClr val="B45309"/>
           </a:solidFill>
           <a:ln>
             <a:noFill/>
@@ -26730,7 +29755,7 @@
             <a:avLst/>
           </a:prstGeom>
           <a:solidFill>
-            <a:srgbClr val="3B82F6"/>
+            <a:srgbClr val="15803D"/>
           </a:solidFill>
           <a:ln>
             <a:noFill/>
@@ -26868,7 +29893,7 @@
             <a:avLst/>
           </a:prstGeom>
           <a:solidFill>
-            <a:srgbClr val="3B82F6"/>
+            <a:srgbClr val="B91C1C"/>
           </a:solidFill>
           <a:ln>
             <a:noFill/>

</xml_diff>

<commit_message>
feat: Introduce MasterPresentation and MasterSlide for template-driven slide creation
- Added MasterPresentation class to facilitate creating presentations from existing PPTX templates while retaining master layouts.
- Implemented MasterSlide class for fluent editing of individual slides, allowing for placeholder management and component placement.
- Enhanced SlideBuilder to support background images and logos, with appropriate warnings for missing files.
- Updated theme handling to include additional accent colors (ACCENT_2, ACCENT_3) and improved default theme palette for charts.
- Refactored chart components to utilize the new theme palette for consistent color application.
- Added tests for new features, including theme loading from JSON/YAML and logo/background image handling.
</commit_message>
<xml_diff>
--- a/examples/demo_dark.pptx
+++ b/examples/demo_dark.pptx
@@ -253,7 +253,7 @@
           </c:tx>
           <c:spPr>
             <a:solidFill>
-              <a:srgbClr val="2563EB"/>
+              <a:srgbClr val="10B981"/>
             </a:solidFill>
             <a:ln>
               <a:noFill/>
@@ -546,7 +546,7 @@
           <c:spPr>
             <a:ln w="31750">
               <a:solidFill>
-                <a:srgbClr val="2563EB"/>
+                <a:srgbClr val="10B981"/>
               </a:solidFill>
             </a:ln>
           </c:spPr>
@@ -807,7 +807,7 @@
             <c:idx val="3"/>
             <c:spPr>
               <a:solidFill>
-                <a:srgbClr val="8B5CF6"/>
+                <a:srgbClr val="2563EB"/>
               </a:solidFill>
             </c:spPr>
           </c:dPt>
@@ -1196,7 +1196,7 @@
           </c:tx>
           <c:spPr>
             <a:solidFill>
-              <a:srgbClr val="2563EB"/>
+              <a:srgbClr val="10B981"/>
             </a:solidFill>
             <a:ln>
               <a:noFill/>
@@ -1418,7 +1418,7 @@
             <c:idx val="3"/>
             <c:spPr>
               <a:solidFill>
-                <a:srgbClr val="8B5CF6"/>
+                <a:srgbClr val="2563EB"/>
               </a:solidFill>
             </c:spPr>
           </c:dPt>
@@ -1648,7 +1648,7 @@
           <c:spPr>
             <a:ln w="31750">
               <a:solidFill>
-                <a:srgbClr val="2563EB"/>
+                <a:srgbClr val="10B981"/>
               </a:solidFill>
             </a:ln>
           </c:spPr>
@@ -11875,7 +11875,7 @@
             </a:avLst>
           </a:prstGeom>
           <a:solidFill>
-            <a:srgbClr val="3870CA"/>
+            <a:srgbClr val="E3791F"/>
           </a:solidFill>
           <a:ln>
             <a:noFill/>
@@ -11955,7 +11955,7 @@
             </a:avLst>
           </a:prstGeom>
           <a:solidFill>
-            <a:srgbClr val="3976D8"/>
+            <a:srgbClr val="BF6E50"/>
           </a:solidFill>
           <a:ln>
             <a:noFill/>
@@ -12035,7 +12035,7 @@
             </a:avLst>
           </a:prstGeom>
           <a:solidFill>
-            <a:srgbClr val="3762A9"/>
+            <a:srgbClr val="25B277"/>
           </a:solidFill>
           <a:ln>
             <a:noFill/>
@@ -12115,7 +12115,7 @@
             </a:avLst>
           </a:prstGeom>
           <a:solidFill>
-            <a:srgbClr val="3A7CE7"/>
+            <a:srgbClr val="72689D"/>
           </a:solidFill>
           <a:ln>
             <a:noFill/>
@@ -12230,7 +12230,7 @@
             </a:avLst>
           </a:prstGeom>
           <a:solidFill>
-            <a:srgbClr val="365A93"/>
+            <a:srgbClr val="23A0B6"/>
           </a:solidFill>
           <a:ln>
             <a:noFill/>
@@ -12310,7 +12310,7 @@
             </a:avLst>
           </a:prstGeom>
           <a:solidFill>
-            <a:srgbClr val="355484"/>
+            <a:srgbClr val="338CE0"/>
           </a:solidFill>
           <a:ln>
             <a:noFill/>
@@ -12390,7 +12390,7 @@
             </a:avLst>
           </a:prstGeom>
           <a:solidFill>
-            <a:srgbClr val="3767B4"/>
+            <a:srgbClr val="649F5A"/>
           </a:solidFill>
           <a:ln>
             <a:noFill/>
@@ -12470,7 +12470,7 @@
             </a:avLst>
           </a:prstGeom>
           <a:solidFill>
-            <a:srgbClr val="365D9A"/>
+            <a:srgbClr val="1BAAA0"/>
           </a:solidFill>
           <a:ln>
             <a:noFill/>
@@ -12585,7 +12585,7 @@
             </a:avLst>
           </a:prstGeom>
           <a:solidFill>
-            <a:srgbClr val="3A7CE7"/>
+            <a:srgbClr val="72689D"/>
           </a:solidFill>
           <a:ln>
             <a:noFill/>
@@ -12665,7 +12665,7 @@
             </a:avLst>
           </a:prstGeom>
           <a:solidFill>
-            <a:srgbClr val="3A7FEE"/>
+            <a:srgbClr val="4B65C4"/>
           </a:solidFill>
           <a:ln>
             <a:noFill/>
@@ -12745,7 +12745,7 @@
             </a:avLst>
           </a:prstGeom>
           <a:solidFill>
-            <a:srgbClr val="3979E0"/>
+            <a:srgbClr val="986B76"/>
           </a:solidFill>
           <a:ln>
             <a:noFill/>
@@ -12825,7 +12825,7 @@
             </a:avLst>
           </a:prstGeom>
           <a:solidFill>
-            <a:srgbClr val="3B82F6"/>
+            <a:srgbClr val="2563EB"/>
           </a:solidFill>
           <a:ln>
             <a:noFill/>
@@ -12940,7 +12940,7 @@
             </a:avLst>
           </a:prstGeom>
           <a:solidFill>
-            <a:srgbClr val="34496A"/>
+            <a:srgbClr val="3764AC"/>
           </a:solidFill>
           <a:ln>
             <a:noFill/>
@@ -13100,7 +13100,7 @@
             </a:avLst>
           </a:prstGeom>
           <a:solidFill>
-            <a:srgbClr val="35578B"/>
+            <a:srgbClr val="2B96CB"/>
           </a:solidFill>
           <a:ln>
             <a:noFill/>
@@ -13180,7 +13180,7 @@
             </a:avLst>
           </a:prstGeom>
           <a:solidFill>
-            <a:srgbClr val="344C72"/>
+            <a:srgbClr val="3870CA"/>
           </a:solidFill>
           <a:ln>
             <a:noFill/>

</xml_diff>